<commit_message>
Include final frame inventory in report
</commit_message>
<xml_diff>
--- a/outputs/019ff91b-7d05-7643-8f3b-9fe2b738766a/frame_canonicalization_internal_report.pptx
+++ b/outputs/019ff91b-7d05-7643-8f3b-9fe2b738766a/frame_canonicalization_internal_report.pptx
@@ -2,17 +2,17 @@
 <file path=ppt/presentation.xml><?xml version="1.0" encoding="utf-8"?>
 <p:presentation xmlns:p="http://schemas.openxmlformats.org/presentationml/2006/main">
   <p:sldMasterIdLst>
-    <p:sldMasterId xmlns:r="http://schemas.openxmlformats.org/officeDocument/2006/relationships" id="2147483648" r:id="Rca1e08bbacfc4e2b"/>
+    <p:sldMasterId xmlns:r="http://schemas.openxmlformats.org/officeDocument/2006/relationships" id="2147483648" r:id="Rcb644aa4777d4b43"/>
   </p:sldMasterIdLst>
   <p:notesMasterIdLst>
-    <p:notesMasterId xmlns:r="http://schemas.openxmlformats.org/officeDocument/2006/relationships" r:id="Rac5381c6aa5f4beb"/>
+    <p:notesMasterId xmlns:r="http://schemas.openxmlformats.org/officeDocument/2006/relationships" r:id="R24b8f9501a7d40aa"/>
   </p:notesMasterIdLst>
   <p:sldIdLst>
-    <p:sldId xmlns:r="http://schemas.openxmlformats.org/officeDocument/2006/relationships" id="256" r:id="Rf66bd0cfb1b84306"/>
-    <p:sldId xmlns:r="http://schemas.openxmlformats.org/officeDocument/2006/relationships" id="257" r:id="Rff3ede917e764886"/>
-    <p:sldId xmlns:r="http://schemas.openxmlformats.org/officeDocument/2006/relationships" id="258" r:id="R1ce8869928c749f0"/>
-    <p:sldId xmlns:r="http://schemas.openxmlformats.org/officeDocument/2006/relationships" id="259" r:id="R96d7defac1b94c81"/>
-    <p:sldId xmlns:r="http://schemas.openxmlformats.org/officeDocument/2006/relationships" id="260" r:id="Rae144f5f4e0b4aaa"/>
+    <p:sldId xmlns:r="http://schemas.openxmlformats.org/officeDocument/2006/relationships" id="256" r:id="R7f931bf703064d08"/>
+    <p:sldId xmlns:r="http://schemas.openxmlformats.org/officeDocument/2006/relationships" id="257" r:id="R8147b5b50a4741da"/>
+    <p:sldId xmlns:r="http://schemas.openxmlformats.org/officeDocument/2006/relationships" id="258" r:id="R4803df134a63448b"/>
+    <p:sldId xmlns:r="http://schemas.openxmlformats.org/officeDocument/2006/relationships" id="259" r:id="R58bde719c0574780"/>
+    <p:sldId xmlns:r="http://schemas.openxmlformats.org/officeDocument/2006/relationships" id="260" r:id="R6a8c69edff6144f5"/>
   </p:sldIdLst>
   <p:sldSz cx="12192000" cy="6858000"/>
   <p:notesSz cx="6858000" cy="9144000"/>
@@ -446,6 +446,11 @@
           <a:lstStyle xmlns:a="http://schemas.openxmlformats.org/drawingml/2006/main"/>
           <a:p xmlns:a="http://schemas.openxmlformats.org/drawingml/2006/main">
             <a:r>
+              <a:t>Claim boundary: reduction is measured; precision, recall, FE-role accuracy and valid-frame loss are not yet measured.</a:t>
+            </a:r>
+          </a:p>
+          <a:p xmlns:a="http://schemas.openxmlformats.org/drawingml/2006/main">
+            <a:r>
               <a:t>[Sources]</a:t>
             </a:r>
           </a:p>
@@ -457,6 +462,11 @@
           <a:p xmlns:a="http://schemas.openxmlformats.org/drawingml/2006/main">
             <a:r>
               <a:t>- D:\Deduplication_Agent\outputs\procedure_sentences_canonicalized.csv</a:t>
+            </a:r>
+          </a:p>
+          <a:p xmlns:a="http://schemas.openxmlformats.org/drawingml/2006/main">
+            <a:r>
+              <a:t>- D:\Deduplication_Agent\domain_frame_canonicalizer.py</a:t>
             </a:r>
           </a:p>
         </p:txBody>
@@ -526,12 +536,22 @@
           <a:lstStyle xmlns:a="http://schemas.openxmlformats.org/drawingml/2006/main"/>
           <a:p xmlns:a="http://schemas.openxmlformats.org/drawingml/2006/main">
             <a:r>
+              <a:t>Inventory grouping is presentational; CANONICAL_DOMAIN_FRAMES is the authoritative flat set.</a:t>
+            </a:r>
+          </a:p>
+          <a:p xmlns:a="http://schemas.openxmlformats.org/drawingml/2006/main">
+            <a:r>
               <a:t>[Sources]</a:t>
             </a:r>
           </a:p>
           <a:p xmlns:a="http://schemas.openxmlformats.org/drawingml/2006/main">
             <a:r>
               <a:t>- D:\Deduplication_Agent\domain_frame_canonicalizer.py</a:t>
+            </a:r>
+          </a:p>
+          <a:p xmlns:a="http://schemas.openxmlformats.org/drawingml/2006/main">
+            <a:r>
+              <a:t>- D:\Deduplication_Agent\outputs\procedure_sentences_canonicalized.csv</a:t>
             </a:r>
           </a:p>
           <a:p xmlns:a="http://schemas.openxmlformats.org/drawingml/2006/main">
@@ -606,6 +626,11 @@
           <a:lstStyle xmlns:a="http://schemas.openxmlformats.org/drawingml/2006/main"/>
           <a:p xmlns:a="http://schemas.openxmlformats.org/drawingml/2006/main">
             <a:r>
+              <a:t>22.5% = 4,233 Imposing_obligation assignments / 18,785 total canonical assignments. Queue effort should be estimated as queue size × measured median minutes per item after a timing pilot.</a:t>
+            </a:r>
+          </a:p>
+          <a:p xmlns:a="http://schemas.openxmlformats.org/drawingml/2006/main">
+            <a:r>
               <a:t>[Sources]</a:t>
             </a:r>
           </a:p>
@@ -617,6 +642,11 @@
           <a:p xmlns:a="http://schemas.openxmlformats.org/drawingml/2006/main">
             <a:r>
               <a:t>- D:\Deduplication_Agent\outputs\procedure_sentences_canonicalized.csv</a:t>
+            </a:r>
+          </a:p>
+          <a:p xmlns:a="http://schemas.openxmlformats.org/drawingml/2006/main">
+            <a:r>
+              <a:t>- D:\Deduplication_Agent\domain_frame_canonicalizer.py</a:t>
             </a:r>
           </a:p>
         </p:txBody>
@@ -686,6 +716,11 @@
           <a:lstStyle xmlns:a="http://schemas.openxmlformats.org/drawingml/2006/main"/>
           <a:p xmlns:a="http://schemas.openxmlformats.org/drawingml/2006/main">
             <a:r>
+              <a:t>The displayed snippets are shortened from exact procedure_sentences_canonicalized.csv rows. FE-role correctness requires separate gold annotations.</a:t>
+            </a:r>
+          </a:p>
+          <a:p xmlns:a="http://schemas.openxmlformats.org/drawingml/2006/main">
+            <a:r>
               <a:t>[Sources]</a:t>
             </a:r>
           </a:p>
@@ -696,12 +731,12 @@
           </a:p>
           <a:p xmlns:a="http://schemas.openxmlformats.org/drawingml/2006/main">
             <a:r>
-              <a:t>- D:\Deduplication_Agent\outputs\procedure_frame_canonicalization_summary.json</a:t>
-            </a:r>
-          </a:p>
-          <a:p xmlns:a="http://schemas.openxmlformats.org/drawingml/2006/main">
-            <a:r>
               <a:t>- D:\Deduplication_Agent\domain_frame_canonicalizer.py</a:t>
+            </a:r>
+          </a:p>
+          <a:p xmlns:a="http://schemas.openxmlformats.org/drawingml/2006/main">
+            <a:r>
+              <a:t>- D:\Deduplication_Agent\test_domain_frame_canonicalizer.py</a:t>
             </a:r>
           </a:p>
         </p:txBody>
@@ -771,6 +806,11 @@
           <a:lstStyle xmlns:a="http://schemas.openxmlformats.org/drawingml/2006/main"/>
           <a:p xmlns:a="http://schemas.openxmlformats.org/drawingml/2006/main">
             <a:r>
+              <a:t>The ≥90% precision threshold is a proposed gate for client approval, not a measured result. Recall and FE-role metrics must be reported before production.</a:t>
+            </a:r>
+          </a:p>
+          <a:p xmlns:a="http://schemas.openxmlformats.org/drawingml/2006/main">
+            <a:r>
               <a:t>[Sources]</a:t>
             </a:r>
           </a:p>
@@ -786,12 +826,12 @@
           </a:p>
           <a:p xmlns:a="http://schemas.openxmlformats.org/drawingml/2006/main">
             <a:r>
+              <a:t>- D:\Deduplication_Agent\domain_frame_canonicalizer.py</a:t>
+            </a:r>
+          </a:p>
+          <a:p xmlns:a="http://schemas.openxmlformats.org/drawingml/2006/main">
+            <a:r>
               <a:t>- D:\Deduplication_Agent\test_domain_frame_canonicalizer.py</a:t>
-            </a:r>
-          </a:p>
-          <a:p xmlns:a="http://schemas.openxmlformats.org/drawingml/2006/main">
-            <a:r>
-              <a:t>- D:\Deduplication_Agent\domain_frame_canonicalizer.py</a:t>
             </a:r>
           </a:p>
         </p:txBody>
@@ -859,7 +899,7 @@
   </p:cSld>
   <p:clrMap bg1="lt1" tx1="dk1" bg2="lt2" tx2="dk2" accent1="accent1" accent2="accent2" accent3="accent3" accent4="accent4" accent5="accent5" accent6="accent6" hlink="hlink" folHlink="folHlink"/>
   <p:sldLayoutIdLst>
-    <p:sldLayoutId xmlns:r="http://schemas.openxmlformats.org/officeDocument/2006/relationships" id="2147483649" r:id="Rced961a03c884cd3"/>
+    <p:sldLayoutId xmlns:r="http://schemas.openxmlformats.org/officeDocument/2006/relationships" id="2147483649" r:id="Rbfb9f57dc0a84e46"/>
   </p:sldLayoutIdLst>
   <p:txStyles>
     <p:titleStyle>
@@ -1672,7 +1712,7 @@
                 <a:ea typeface="Arial"/>
                 <a:cs typeface="Arial"/>
               </a:rPr>
-              <a:t>Canonicalization sharply reduced frame ambiguity</a:t>
+              <a:t>Ambiguity is lower; accuracy is not yet proven</a:t>
             </a:r>
           </a:p>
         </p:txBody>
@@ -1734,7 +1774,7 @@
                 <a:ea typeface="Arial"/>
                 <a:cs typeface="Arial"/>
               </a:rPr>
-              <a:t>Full-corpus rerun: 17,244 procedure sentences. The patch favors precision and preserves uncertain cases for review.</a:t>
+              <a:t>Inventory v1 contains 26 recurring procedure frames; 25 were observed. Replacing is the unused provisional frame.</a:t>
             </a:r>
           </a:p>
         </p:txBody>
@@ -1926,7 +1966,7 @@
         </p:spPr>
         <p:txBody>
           <a:bodyPr xmlns:a="http://schemas.openxmlformats.org/drawingml/2006/main" lIns="0" tIns="0" rIns="0" bIns="0" anchor="t">
-            <a:normAutofit fontScale="100000"/>
+            <a:normAutofit fontScale="88706"/>
           </a:bodyPr>
           <a:lstStyle xmlns:a="http://schemas.openxmlformats.org/drawingml/2006/main"/>
           <a:p xmlns:a="http://schemas.openxmlformats.org/drawingml/2006/main">
@@ -1953,14 +1993,14 @@
                 <a:ea typeface="Arial"/>
                 <a:cs typeface="Arial"/>
               </a:rPr>
-              <a:t>distinct frame names</a:t>
+              <a:t>candidates → observed frames</a:t>
             </a:r>
           </a:p>
         </p:txBody>
       </p:sp>
       <p:cxnSp>
         <p:nvCxnSpPr>
-          <p:cNvPr id="31" name="metric-rule-1"/>
+          <p:cNvPr id="99" name="metric-rule-1"/>
           <p:cNvCxnSpPr/>
           <p:nvPr/>
         </p:nvCxnSpPr>
@@ -2037,7 +2077,7 @@
                 <a:ea typeface="Arial"/>
                 <a:cs typeface="Arial"/>
               </a:rPr>
-              <a:t>97.1% smaller observed inventory</a:t>
+              <a:t>26 approved; Replacing unobserved.</a:t>
             </a:r>
           </a:p>
         </p:txBody>
@@ -2201,7 +2241,7 @@
       </p:sp>
       <p:cxnSp>
         <p:nvCxnSpPr>
-          <p:cNvPr id="36" name="metric-rule-2"/>
+          <p:cNvPr id="104" name="metric-rule-2"/>
           <p:cNvCxnSpPr/>
           <p:nvPr/>
         </p:nvCxnSpPr>
@@ -2278,7 +2318,7 @@
                 <a:ea typeface="Arial"/>
                 <a:cs typeface="Arial"/>
               </a:rPr>
-              <a:t>94.2% less assignment noise</a:t>
+              <a:t>Ambiguity fell; valid-frame loss is unmeasured.</a:t>
             </a:r>
           </a:p>
         </p:txBody>
@@ -2435,14 +2475,14 @@
                 <a:ea typeface="Arial"/>
                 <a:cs typeface="Arial"/>
               </a:rPr>
-              <a:t>automatically resolved</a:t>
+              <a:t>auto-routed outcome</a:t>
             </a:r>
           </a:p>
         </p:txBody>
       </p:sp>
       <p:cxnSp>
         <p:nvCxnSpPr>
-          <p:cNvPr id="41" name="metric-rule-3"/>
+          <p:cNvPr id="109" name="metric-rule-3"/>
           <p:cNvCxnSpPr/>
           <p:nvPr/>
         </p:nvCxnSpPr>
@@ -2519,7 +2559,7 @@
                 <a:ea typeface="Arial"/>
                 <a:cs typeface="Arial"/>
               </a:rPr>
-              <a:t>4,075 retained for review</a:t>
+              <a:t>11,434 canonical + 95 structured; not gold-validated.</a:t>
             </a:r>
           </a:p>
         </p:txBody>
@@ -2581,7 +2621,7 @@
                 <a:ea typeface="Arial"/>
                 <a:cs typeface="Arial"/>
               </a:rPr>
-              <a:t>Disposition after patch</a:t>
+              <a:t>Exact definition</a:t>
             </a:r>
           </a:p>
         </p:txBody>
@@ -2775,7 +2815,7 @@
                 <a:ea typeface="Arial"/>
                 <a:cs typeface="Arial"/>
               </a:rPr>
-              <a:t>66.3% canonical   •   23.6% review   •   9.4% no domain   •   0.6% structured / filtered</a:t>
+              <a:t>66.9% = canonical + structured • excludes 4,075 review, 1,625 no-domain and 15 artifacts</a:t>
             </a:r>
           </a:p>
         </p:txBody>
@@ -2839,7 +2879,7 @@
         </p:spPr>
         <p:txBody>
           <a:bodyPr xmlns:a="http://schemas.openxmlformats.org/drawingml/2006/main" lIns="0" tIns="0" rIns="0" bIns="0" anchor="t">
-            <a:normAutofit fontScale="87503"/>
+            <a:normAutofit fontScale="100000"/>
           </a:bodyPr>
           <a:lstStyle xmlns:a="http://schemas.openxmlformats.org/drawingml/2006/main"/>
           <a:p xmlns:a="http://schemas.openxmlformats.org/drawingml/2006/main">
@@ -2866,7 +2906,7 @@
                 <a:ea typeface="Arial"/>
                 <a:cs typeface="Arial"/>
               </a:rPr>
-              <a:t>The patch separates lexical candidates from domain decisions</a:t>
+              <a:t>The final inventory contains 26 procedure frames</a:t>
             </a:r>
           </a:p>
         </p:txBody>
@@ -2928,7 +2968,7 @@
                 <a:ea typeface="Arial"/>
                 <a:cs typeface="Arial"/>
               </a:rPr>
-              <a:t>A raw lexical-unit match is now evidence to evaluate—not a final frame label.</a:t>
+              <a:t>These 26 are eligible for automatic canonical output; wider FrameNet candidates remain preserved for audit.</a:t>
             </a:r>
           </a:p>
         </p:txBody>
@@ -2997,7 +3037,7 @@
       </p:sp>
       <p:cxnSp>
         <p:nvCxnSpPr>
-          <p:cNvPr id="26" name="pipeline-line"/>
+          <p:cNvPr id="42" name="pipeline-line"/>
           <p:cNvCxnSpPr/>
           <p:nvPr/>
         </p:nvCxnSpPr>
@@ -3107,7 +3147,7 @@
                 <a:ea typeface="Arial"/>
                 <a:cs typeface="Arial"/>
               </a:rPr>
-              <a:t>01  RAW CANDIDATES</a:t>
+              <a:t>01  DECISION / EVIDENCE</a:t>
             </a:r>
           </a:p>
         </p:txBody>
@@ -3169,7 +3209,7 @@
                 <a:ea typeface="Arial"/>
                 <a:cs typeface="Arial"/>
               </a:rPr>
-              <a:t>Keep recall high</a:t>
+              <a:t>Interpret / assess</a:t>
             </a:r>
           </a:p>
         </p:txBody>
@@ -3190,8 +3230,265 @@
         </p:nvSpPr>
         <p:spPr>
           <a:xfrm xmlns:a="http://schemas.openxmlformats.org/drawingml/2006/main">
-            <a:off x="457200" y="3924300"/>
-            <a:ext cx="2524125" cy="1162050"/>
+            <a:off x="457200" y="3876675"/>
+            <a:ext cx="2524125" cy="1504950"/>
+          </a:xfrm>
+          <a:prstGeom xmlns:a="http://schemas.openxmlformats.org/drawingml/2006/main" prst="rect">
+            <a:avLst/>
+          </a:prstGeom>
+          <a:noFill xmlns:a="http://schemas.openxmlformats.org/drawingml/2006/main"/>
+          <a:ln xmlns:a="http://schemas.openxmlformats.org/drawingml/2006/main" w="0">
+            <a:noFill/>
+            <a:prstDash val="solid"/>
+          </a:ln>
+        </p:spPr>
+        <p:txBody>
+          <a:bodyPr xmlns:a="http://schemas.openxmlformats.org/drawingml/2006/main" lIns="0" tIns="0" rIns="0" bIns="0" anchor="t">
+            <a:normAutofit fontScale="99521"/>
+          </a:bodyPr>
+          <a:lstStyle xmlns:a="http://schemas.openxmlformats.org/drawingml/2006/main"/>
+          <a:p xmlns:a="http://schemas.openxmlformats.org/drawingml/2006/main">
+            <a:pPr algn="l">
+              <a:lnSpc>
+                <a:spcPct val="105000"/>
+              </a:lnSpc>
+              <a:buNone/>
+              <a:defRPr sz="1575" b="0">
+                <a:solidFill>
+                  <a:srgbClr val="5B616B"/>
+                </a:solidFill>
+                <a:latin typeface="Arial"/>
+                <a:ea typeface="Arial"/>
+                <a:cs typeface="Arial"/>
+              </a:defRPr>
+            </a:pPr>
+            <a:r>
+              <a:rPr sz="1350" b="0">
+                <a:solidFill>
+                  <a:srgbClr val="5B616B"/>
+                </a:solidFill>
+                <a:latin typeface="Arial"/>
+                <a:ea typeface="Arial"/>
+                <a:cs typeface="Arial"/>
+              </a:rPr>
+              <a:t>Assessing</a:t>
+            </a:r>
+          </a:p>
+          <a:p xmlns:a="http://schemas.openxmlformats.org/drawingml/2006/main">
+            <a:pPr algn="l">
+              <a:lnSpc>
+                <a:spcPct val="105000"/>
+              </a:lnSpc>
+              <a:buNone/>
+              <a:defRPr sz="1575" b="0">
+                <a:solidFill>
+                  <a:srgbClr val="5B616B"/>
+                </a:solidFill>
+                <a:latin typeface="Arial"/>
+                <a:ea typeface="Arial"/>
+                <a:cs typeface="Arial"/>
+              </a:defRPr>
+            </a:pPr>
+            <a:r>
+              <a:rPr sz="1350" b="0">
+                <a:solidFill>
+                  <a:srgbClr val="5B616B"/>
+                </a:solidFill>
+                <a:latin typeface="Arial"/>
+                <a:ea typeface="Arial"/>
+                <a:cs typeface="Arial"/>
+              </a:rPr>
+              <a:t>Coming_to_believe</a:t>
+            </a:r>
+          </a:p>
+          <a:p xmlns:a="http://schemas.openxmlformats.org/drawingml/2006/main">
+            <a:pPr algn="l">
+              <a:lnSpc>
+                <a:spcPct val="105000"/>
+              </a:lnSpc>
+              <a:buNone/>
+              <a:defRPr sz="1575" b="0">
+                <a:solidFill>
+                  <a:srgbClr val="5B616B"/>
+                </a:solidFill>
+                <a:latin typeface="Arial"/>
+                <a:ea typeface="Arial"/>
+                <a:cs typeface="Arial"/>
+              </a:defRPr>
+            </a:pPr>
+            <a:r>
+              <a:rPr sz="1350" b="0">
+                <a:solidFill>
+                  <a:srgbClr val="5B616B"/>
+                </a:solidFill>
+                <a:latin typeface="Arial"/>
+                <a:ea typeface="Arial"/>
+                <a:cs typeface="Arial"/>
+              </a:rPr>
+              <a:t>Deciding</a:t>
+            </a:r>
+          </a:p>
+          <a:p xmlns:a="http://schemas.openxmlformats.org/drawingml/2006/main">
+            <a:pPr algn="l">
+              <a:lnSpc>
+                <a:spcPct val="105000"/>
+              </a:lnSpc>
+              <a:buNone/>
+              <a:defRPr sz="1575" b="0">
+                <a:solidFill>
+                  <a:srgbClr val="5B616B"/>
+                </a:solidFill>
+                <a:latin typeface="Arial"/>
+                <a:ea typeface="Arial"/>
+                <a:cs typeface="Arial"/>
+              </a:defRPr>
+            </a:pPr>
+            <a:r>
+              <a:rPr sz="1350" b="0">
+                <a:solidFill>
+                  <a:srgbClr val="5B616B"/>
+                </a:solidFill>
+                <a:latin typeface="Arial"/>
+                <a:ea typeface="Arial"/>
+                <a:cs typeface="Arial"/>
+              </a:rPr>
+              <a:t>Evidence</a:t>
+            </a:r>
+          </a:p>
+          <a:p xmlns:a="http://schemas.openxmlformats.org/drawingml/2006/main">
+            <a:pPr algn="l">
+              <a:lnSpc>
+                <a:spcPct val="105000"/>
+              </a:lnSpc>
+              <a:buNone/>
+              <a:defRPr sz="1575" b="0">
+                <a:solidFill>
+                  <a:srgbClr val="5B616B"/>
+                </a:solidFill>
+                <a:latin typeface="Arial"/>
+                <a:ea typeface="Arial"/>
+                <a:cs typeface="Arial"/>
+              </a:defRPr>
+            </a:pPr>
+            <a:r>
+              <a:rPr sz="1350" b="0">
+                <a:solidFill>
+                  <a:srgbClr val="5B616B"/>
+                </a:solidFill>
+                <a:latin typeface="Arial"/>
+                <a:ea typeface="Arial"/>
+                <a:cs typeface="Arial"/>
+              </a:rPr>
+              <a:t>Scrutiny</a:t>
+            </a:r>
+          </a:p>
+          <a:p xmlns:a="http://schemas.openxmlformats.org/drawingml/2006/main">
+            <a:pPr algn="l">
+              <a:lnSpc>
+                <a:spcPct val="105000"/>
+              </a:lnSpc>
+              <a:buNone/>
+              <a:defRPr sz="1575" b="0">
+                <a:solidFill>
+                  <a:srgbClr val="5B616B"/>
+                </a:solidFill>
+                <a:latin typeface="Arial"/>
+                <a:ea typeface="Arial"/>
+                <a:cs typeface="Arial"/>
+              </a:defRPr>
+            </a:pPr>
+            <a:r>
+              <a:rPr sz="1350" b="0">
+                <a:solidFill>
+                  <a:srgbClr val="5B616B"/>
+                </a:solidFill>
+                <a:latin typeface="Arial"/>
+                <a:ea typeface="Arial"/>
+                <a:cs typeface="Arial"/>
+              </a:rPr>
+              <a:t>Meet_specifications</a:t>
+            </a:r>
+          </a:p>
+          <a:p xmlns:a="http://schemas.openxmlformats.org/drawingml/2006/main">
+            <a:pPr algn="l">
+              <a:lnSpc>
+                <a:spcPct val="105000"/>
+              </a:lnSpc>
+              <a:buNone/>
+              <a:defRPr sz="1575" b="0">
+                <a:solidFill>
+                  <a:srgbClr val="5B616B"/>
+                </a:solidFill>
+                <a:latin typeface="Arial"/>
+                <a:ea typeface="Arial"/>
+                <a:cs typeface="Arial"/>
+              </a:defRPr>
+            </a:pPr>
+            <a:r>
+              <a:rPr sz="1350" b="0">
+                <a:solidFill>
+                  <a:srgbClr val="5B616B"/>
+                </a:solidFill>
+                <a:latin typeface="Arial"/>
+                <a:ea typeface="Arial"/>
+                <a:cs typeface="Arial"/>
+              </a:rPr>
+              <a:t>Have_as_requirement</a:t>
+            </a:r>
+          </a:p>
+        </p:txBody>
+      </p:sp>
+      <p:sp>
+        <p:nvSpPr>
+          <p:cNvPr id="9" name="pipeline-dot-2">
+            <a:extLst xmlns:a="http://schemas.openxmlformats.org/drawingml/2006/main">
+              <a:ext uri="{FF2B5EF4-FFF2-40B4-BE49-F238E27FC236}">
+                <a16:creationId xmlns:a16="http://schemas.microsoft.com/office/drawing/2014/main" id="{DC8DD7FA-9E0C-48E2-964F-7EAC42D663D1}"/>
+              </a:ext>
+            </a:extLst>
+          </p:cNvPr>
+          <p:cNvSpPr>
+            <a:spLocks xmlns:a="http://schemas.openxmlformats.org/drawingml/2006/main" noGrp="1"/>
+          </p:cNvSpPr>
+          <p:nvPr/>
+        </p:nvSpPr>
+        <p:spPr>
+          <a:xfrm xmlns:a="http://schemas.openxmlformats.org/drawingml/2006/main">
+            <a:off x="3362325" y="2867025"/>
+            <a:ext cx="171450" cy="171450"/>
+          </a:xfrm>
+          <a:prstGeom xmlns:a="http://schemas.openxmlformats.org/drawingml/2006/main" prst="ellipse">
+            <a:avLst/>
+          </a:prstGeom>
+          <a:solidFill xmlns:a="http://schemas.openxmlformats.org/drawingml/2006/main">
+            <a:srgbClr val="000000"/>
+          </a:solidFill>
+          <a:ln xmlns:a="http://schemas.openxmlformats.org/drawingml/2006/main" w="0">
+            <a:solidFill>
+              <a:srgbClr val="000000"/>
+            </a:solidFill>
+            <a:prstDash val="solid"/>
+          </a:ln>
+        </p:spPr>
+      </p:sp>
+      <p:sp>
+        <p:nvSpPr>
+          <p:cNvPr id="10" name="pipeline-label-2">
+            <a:extLst xmlns:a="http://schemas.openxmlformats.org/drawingml/2006/main">
+              <a:ext uri="{FF2B5EF4-FFF2-40B4-BE49-F238E27FC236}">
+                <a16:creationId xmlns:a16="http://schemas.microsoft.com/office/drawing/2014/main" id="{A1642D74-7CA3-4E05-943B-1EAB89479B81}"/>
+              </a:ext>
+            </a:extLst>
+          </p:cNvPr>
+          <p:cNvSpPr>
+            <a:spLocks xmlns:a="http://schemas.openxmlformats.org/drawingml/2006/main" noGrp="1"/>
+          </p:cNvSpPr>
+          <p:nvPr/>
+        </p:nvSpPr>
+        <p:spPr>
+          <a:xfrm xmlns:a="http://schemas.openxmlformats.org/drawingml/2006/main">
+            <a:off x="3362325" y="2381250"/>
+            <a:ext cx="2524125" cy="323850"/>
           </a:xfrm>
           <a:prstGeom xmlns:a="http://schemas.openxmlformats.org/drawingml/2006/main" prst="rect">
             <a:avLst/>
@@ -3210,83 +3507,50 @@
           <a:p xmlns:a="http://schemas.openxmlformats.org/drawingml/2006/main">
             <a:pPr algn="l">
               <a:lnSpc>
-                <a:spcPct val="105000"/>
-              </a:lnSpc>
-              <a:buNone/>
-              <a:defRPr sz="1575" b="0">
-                <a:solidFill>
-                  <a:srgbClr val="5B616B"/>
-                </a:solidFill>
-                <a:latin typeface="Arial"/>
-                <a:ea typeface="Arial"/>
-                <a:cs typeface="Arial"/>
-              </a:defRPr>
-            </a:pPr>
-            <a:r>
-              <a:rPr sz="1575" b="0">
-                <a:solidFill>
-                  <a:srgbClr val="5B616B"/>
-                </a:solidFill>
-                <a:latin typeface="Arial"/>
-                <a:ea typeface="Arial"/>
-                <a:cs typeface="Arial"/>
-              </a:rPr>
-              <a:t>857 FrameNet names remain available as lexical evidence.</a:t>
+                <a:spcPct val="100000"/>
+              </a:lnSpc>
+              <a:buNone/>
+              <a:defRPr sz="1350" b="1">
+                <a:solidFill>
+                  <a:srgbClr val="5B616B"/>
+                </a:solidFill>
+                <a:latin typeface="Arial"/>
+                <a:ea typeface="Arial"/>
+                <a:cs typeface="Arial"/>
+              </a:defRPr>
+            </a:pPr>
+            <a:r>
+              <a:rPr sz="1350" b="1">
+                <a:solidFill>
+                  <a:srgbClr val="5B616B"/>
+                </a:solidFill>
+                <a:latin typeface="Arial"/>
+                <a:ea typeface="Arial"/>
+                <a:cs typeface="Arial"/>
+              </a:rPr>
+              <a:t>02  DUTIES / INTERACTION</a:t>
             </a:r>
           </a:p>
         </p:txBody>
       </p:sp>
       <p:sp>
         <p:nvSpPr>
-          <p:cNvPr id="9" name="pipeline-dot-2">
-            <a:extLst xmlns:a="http://schemas.openxmlformats.org/drawingml/2006/main">
-              <a:ext uri="{FF2B5EF4-FFF2-40B4-BE49-F238E27FC236}">
-                <a16:creationId xmlns:a16="http://schemas.microsoft.com/office/drawing/2014/main" id="{DC8DD7FA-9E0C-48E2-964F-7EAC42D663D1}"/>
-              </a:ext>
-            </a:extLst>
-          </p:cNvPr>
-          <p:cNvSpPr>
-            <a:spLocks xmlns:a="http://schemas.openxmlformats.org/drawingml/2006/main" noGrp="1"/>
-          </p:cNvSpPr>
-          <p:nvPr/>
-        </p:nvSpPr>
-        <p:spPr>
-          <a:xfrm xmlns:a="http://schemas.openxmlformats.org/drawingml/2006/main">
-            <a:off x="3362325" y="2867025"/>
-            <a:ext cx="171450" cy="171450"/>
-          </a:xfrm>
-          <a:prstGeom xmlns:a="http://schemas.openxmlformats.org/drawingml/2006/main" prst="ellipse">
-            <a:avLst/>
-          </a:prstGeom>
-          <a:solidFill xmlns:a="http://schemas.openxmlformats.org/drawingml/2006/main">
-            <a:srgbClr val="000000"/>
-          </a:solidFill>
-          <a:ln xmlns:a="http://schemas.openxmlformats.org/drawingml/2006/main" w="0">
-            <a:solidFill>
-              <a:srgbClr val="000000"/>
-            </a:solidFill>
-            <a:prstDash val="solid"/>
-          </a:ln>
-        </p:spPr>
-      </p:sp>
-      <p:sp>
-        <p:nvSpPr>
-          <p:cNvPr id="10" name="pipeline-label-2">
-            <a:extLst xmlns:a="http://schemas.openxmlformats.org/drawingml/2006/main">
-              <a:ext uri="{FF2B5EF4-FFF2-40B4-BE49-F238E27FC236}">
-                <a16:creationId xmlns:a16="http://schemas.microsoft.com/office/drawing/2014/main" id="{A1642D74-7CA3-4E05-943B-1EAB89479B81}"/>
-              </a:ext>
-            </a:extLst>
-          </p:cNvPr>
-          <p:cNvSpPr>
-            <a:spLocks xmlns:a="http://schemas.openxmlformats.org/drawingml/2006/main" noGrp="1"/>
-          </p:cNvSpPr>
-          <p:nvPr/>
-        </p:nvSpPr>
-        <p:spPr>
-          <a:xfrm xmlns:a="http://schemas.openxmlformats.org/drawingml/2006/main">
-            <a:off x="3362325" y="2381250"/>
-            <a:ext cx="2524125" cy="323850"/>
+          <p:cNvPr id="11" name="pipeline-title-2">
+            <a:extLst xmlns:a="http://schemas.openxmlformats.org/drawingml/2006/main">
+              <a:ext uri="{FF2B5EF4-FFF2-40B4-BE49-F238E27FC236}">
+                <a16:creationId xmlns:a16="http://schemas.microsoft.com/office/drawing/2014/main" id="{2E7559FB-019E-4FB7-96CE-AF40C2C74A29}"/>
+              </a:ext>
+            </a:extLst>
+          </p:cNvPr>
+          <p:cNvSpPr>
+            <a:spLocks xmlns:a="http://schemas.openxmlformats.org/drawingml/2006/main" noGrp="1"/>
+          </p:cNvSpPr>
+          <p:nvPr/>
+        </p:nvSpPr>
+        <p:spPr>
+          <a:xfrm xmlns:a="http://schemas.openxmlformats.org/drawingml/2006/main">
+            <a:off x="3362325" y="3409950"/>
+            <a:ext cx="2524125" cy="361950"/>
           </a:xfrm>
           <a:prstGeom xmlns:a="http://schemas.openxmlformats.org/drawingml/2006/main" prst="rect">
             <a:avLst/>
@@ -3308,47 +3572,304 @@
                 <a:spcPct val="100000"/>
               </a:lnSpc>
               <a:buNone/>
-              <a:defRPr sz="1350" b="1">
-                <a:solidFill>
-                  <a:srgbClr val="5B616B"/>
-                </a:solidFill>
-                <a:latin typeface="Arial"/>
-                <a:ea typeface="Arial"/>
-                <a:cs typeface="Arial"/>
-              </a:defRPr>
-            </a:pPr>
-            <a:r>
-              <a:rPr sz="1350" b="1">
-                <a:solidFill>
-                  <a:srgbClr val="5B616B"/>
-                </a:solidFill>
-                <a:latin typeface="Arial"/>
-                <a:ea typeface="Arial"/>
-                <a:cs typeface="Arial"/>
-              </a:rPr>
-              <a:t>02  CONTEXT RULES</a:t>
+              <a:defRPr sz="1950" b="1">
+                <a:solidFill>
+                  <a:srgbClr val="000000"/>
+                </a:solidFill>
+                <a:latin typeface="Arial"/>
+                <a:ea typeface="Arial"/>
+                <a:cs typeface="Arial"/>
+              </a:defRPr>
+            </a:pPr>
+            <a:r>
+              <a:rPr sz="1950" b="1">
+                <a:solidFill>
+                  <a:srgbClr val="000000"/>
+                </a:solidFill>
+                <a:latin typeface="Arial"/>
+                <a:ea typeface="Arial"/>
+                <a:cs typeface="Arial"/>
+              </a:rPr>
+              <a:t>Direct / communicate</a:t>
             </a:r>
           </a:p>
         </p:txBody>
       </p:sp>
       <p:sp>
         <p:nvSpPr>
-          <p:cNvPr id="11" name="pipeline-title-2">
-            <a:extLst xmlns:a="http://schemas.openxmlformats.org/drawingml/2006/main">
-              <a:ext uri="{FF2B5EF4-FFF2-40B4-BE49-F238E27FC236}">
-                <a16:creationId xmlns:a16="http://schemas.microsoft.com/office/drawing/2014/main" id="{2E7559FB-019E-4FB7-96CE-AF40C2C74A29}"/>
-              </a:ext>
-            </a:extLst>
-          </p:cNvPr>
-          <p:cNvSpPr>
-            <a:spLocks xmlns:a="http://schemas.openxmlformats.org/drawingml/2006/main" noGrp="1"/>
-          </p:cNvSpPr>
-          <p:nvPr/>
-        </p:nvSpPr>
-        <p:spPr>
-          <a:xfrm xmlns:a="http://schemas.openxmlformats.org/drawingml/2006/main">
-            <a:off x="3362325" y="3409950"/>
-            <a:ext cx="2524125" cy="361950"/>
+          <p:cNvPr id="12" name="pipeline-body-2">
+            <a:extLst xmlns:a="http://schemas.openxmlformats.org/drawingml/2006/main">
+              <a:ext uri="{FF2B5EF4-FFF2-40B4-BE49-F238E27FC236}">
+                <a16:creationId xmlns:a16="http://schemas.microsoft.com/office/drawing/2014/main" id="{3D7C48D8-6BB3-4AEB-BA68-C0D010F3A1EF}"/>
+              </a:ext>
+            </a:extLst>
+          </p:cNvPr>
+          <p:cNvSpPr>
+            <a:spLocks xmlns:a="http://schemas.openxmlformats.org/drawingml/2006/main" noGrp="1"/>
+          </p:cNvSpPr>
+          <p:nvPr/>
+        </p:nvSpPr>
+        <p:spPr>
+          <a:xfrm xmlns:a="http://schemas.openxmlformats.org/drawingml/2006/main">
+            <a:off x="3362325" y="3876675"/>
+            <a:ext cx="2524125" cy="1504950"/>
+          </a:xfrm>
+          <a:prstGeom xmlns:a="http://schemas.openxmlformats.org/drawingml/2006/main" prst="rect">
+            <a:avLst/>
+          </a:prstGeom>
+          <a:noFill xmlns:a="http://schemas.openxmlformats.org/drawingml/2006/main"/>
+          <a:ln xmlns:a="http://schemas.openxmlformats.org/drawingml/2006/main" w="0">
+            <a:noFill/>
+            <a:prstDash val="solid"/>
+          </a:ln>
+        </p:spPr>
+        <p:txBody>
+          <a:bodyPr xmlns:a="http://schemas.openxmlformats.org/drawingml/2006/main" lIns="0" tIns="0" rIns="0" bIns="0" anchor="t">
+            <a:normAutofit fontScale="99521"/>
+          </a:bodyPr>
+          <a:lstStyle xmlns:a="http://schemas.openxmlformats.org/drawingml/2006/main"/>
+          <a:p xmlns:a="http://schemas.openxmlformats.org/drawingml/2006/main">
+            <a:pPr algn="l">
+              <a:lnSpc>
+                <a:spcPct val="105000"/>
+              </a:lnSpc>
+              <a:buNone/>
+              <a:defRPr sz="1575" b="0">
+                <a:solidFill>
+                  <a:srgbClr val="5B616B"/>
+                </a:solidFill>
+                <a:latin typeface="Arial"/>
+                <a:ea typeface="Arial"/>
+                <a:cs typeface="Arial"/>
+              </a:defRPr>
+            </a:pPr>
+            <a:r>
+              <a:rPr sz="1350" b="0">
+                <a:solidFill>
+                  <a:srgbClr val="5B616B"/>
+                </a:solidFill>
+                <a:latin typeface="Arial"/>
+                <a:ea typeface="Arial"/>
+                <a:cs typeface="Arial"/>
+              </a:rPr>
+              <a:t>Imposing_obligation</a:t>
+            </a:r>
+          </a:p>
+          <a:p xmlns:a="http://schemas.openxmlformats.org/drawingml/2006/main">
+            <a:pPr algn="l">
+              <a:lnSpc>
+                <a:spcPct val="105000"/>
+              </a:lnSpc>
+              <a:buNone/>
+              <a:defRPr sz="1575" b="0">
+                <a:solidFill>
+                  <a:srgbClr val="5B616B"/>
+                </a:solidFill>
+                <a:latin typeface="Arial"/>
+                <a:ea typeface="Arial"/>
+                <a:cs typeface="Arial"/>
+              </a:defRPr>
+            </a:pPr>
+            <a:r>
+              <a:rPr sz="1350" b="0">
+                <a:solidFill>
+                  <a:srgbClr val="5B616B"/>
+                </a:solidFill>
+                <a:latin typeface="Arial"/>
+                <a:ea typeface="Arial"/>
+                <a:cs typeface="Arial"/>
+              </a:rPr>
+              <a:t>Request</a:t>
+            </a:r>
+          </a:p>
+          <a:p xmlns:a="http://schemas.openxmlformats.org/drawingml/2006/main">
+            <a:pPr algn="l">
+              <a:lnSpc>
+                <a:spcPct val="105000"/>
+              </a:lnSpc>
+              <a:buNone/>
+              <a:defRPr sz="1575" b="0">
+                <a:solidFill>
+                  <a:srgbClr val="5B616B"/>
+                </a:solidFill>
+                <a:latin typeface="Arial"/>
+                <a:ea typeface="Arial"/>
+                <a:cs typeface="Arial"/>
+              </a:defRPr>
+            </a:pPr>
+            <a:r>
+              <a:rPr sz="1350" b="0">
+                <a:solidFill>
+                  <a:srgbClr val="5B616B"/>
+                </a:solidFill>
+                <a:latin typeface="Arial"/>
+                <a:ea typeface="Arial"/>
+                <a:cs typeface="Arial"/>
+              </a:rPr>
+              <a:t>Communication</a:t>
+            </a:r>
+          </a:p>
+          <a:p xmlns:a="http://schemas.openxmlformats.org/drawingml/2006/main">
+            <a:pPr algn="l">
+              <a:lnSpc>
+                <a:spcPct val="105000"/>
+              </a:lnSpc>
+              <a:buNone/>
+              <a:defRPr sz="1575" b="0">
+                <a:solidFill>
+                  <a:srgbClr val="5B616B"/>
+                </a:solidFill>
+                <a:latin typeface="Arial"/>
+                <a:ea typeface="Arial"/>
+                <a:cs typeface="Arial"/>
+              </a:defRPr>
+            </a:pPr>
+            <a:r>
+              <a:rPr sz="1350" b="0">
+                <a:solidFill>
+                  <a:srgbClr val="5B616B"/>
+                </a:solidFill>
+                <a:latin typeface="Arial"/>
+                <a:ea typeface="Arial"/>
+                <a:cs typeface="Arial"/>
+              </a:rPr>
+              <a:t>Reporting</a:t>
+            </a:r>
+          </a:p>
+          <a:p xmlns:a="http://schemas.openxmlformats.org/drawingml/2006/main">
+            <a:pPr algn="l">
+              <a:lnSpc>
+                <a:spcPct val="105000"/>
+              </a:lnSpc>
+              <a:buNone/>
+              <a:defRPr sz="1575" b="0">
+                <a:solidFill>
+                  <a:srgbClr val="5B616B"/>
+                </a:solidFill>
+                <a:latin typeface="Arial"/>
+                <a:ea typeface="Arial"/>
+                <a:cs typeface="Arial"/>
+              </a:defRPr>
+            </a:pPr>
+            <a:r>
+              <a:rPr sz="1350" b="0">
+                <a:solidFill>
+                  <a:srgbClr val="5B616B"/>
+                </a:solidFill>
+                <a:latin typeface="Arial"/>
+                <a:ea typeface="Arial"/>
+                <a:cs typeface="Arial"/>
+              </a:rPr>
+              <a:t>Giving</a:t>
+            </a:r>
+          </a:p>
+          <a:p xmlns:a="http://schemas.openxmlformats.org/drawingml/2006/main">
+            <a:pPr algn="l">
+              <a:lnSpc>
+                <a:spcPct val="105000"/>
+              </a:lnSpc>
+              <a:buNone/>
+              <a:defRPr sz="1575" b="0">
+                <a:solidFill>
+                  <a:srgbClr val="5B616B"/>
+                </a:solidFill>
+                <a:latin typeface="Arial"/>
+                <a:ea typeface="Arial"/>
+                <a:cs typeface="Arial"/>
+              </a:defRPr>
+            </a:pPr>
+            <a:r>
+              <a:rPr sz="1350" b="0">
+                <a:solidFill>
+                  <a:srgbClr val="5B616B"/>
+                </a:solidFill>
+                <a:latin typeface="Arial"/>
+                <a:ea typeface="Arial"/>
+                <a:cs typeface="Arial"/>
+              </a:rPr>
+              <a:t>Receiving</a:t>
+            </a:r>
+          </a:p>
+          <a:p xmlns:a="http://schemas.openxmlformats.org/drawingml/2006/main">
+            <a:pPr algn="l">
+              <a:lnSpc>
+                <a:spcPct val="105000"/>
+              </a:lnSpc>
+              <a:buNone/>
+              <a:defRPr sz="1575" b="0">
+                <a:solidFill>
+                  <a:srgbClr val="5B616B"/>
+                </a:solidFill>
+                <a:latin typeface="Arial"/>
+                <a:ea typeface="Arial"/>
+                <a:cs typeface="Arial"/>
+              </a:defRPr>
+            </a:pPr>
+            <a:r>
+              <a:rPr sz="1350" b="0">
+                <a:solidFill>
+                  <a:srgbClr val="5B616B"/>
+                </a:solidFill>
+                <a:latin typeface="Arial"/>
+                <a:ea typeface="Arial"/>
+                <a:cs typeface="Arial"/>
+              </a:rPr>
+              <a:t>Deny_or_grant_permission</a:t>
+            </a:r>
+          </a:p>
+        </p:txBody>
+      </p:sp>
+      <p:sp>
+        <p:nvSpPr>
+          <p:cNvPr id="13" name="pipeline-dot-3">
+            <a:extLst xmlns:a="http://schemas.openxmlformats.org/drawingml/2006/main">
+              <a:ext uri="{FF2B5EF4-FFF2-40B4-BE49-F238E27FC236}">
+                <a16:creationId xmlns:a16="http://schemas.microsoft.com/office/drawing/2014/main" id="{8034CDC0-BDF0-499C-AF72-11E63E200821}"/>
+              </a:ext>
+            </a:extLst>
+          </p:cNvPr>
+          <p:cNvSpPr>
+            <a:spLocks xmlns:a="http://schemas.openxmlformats.org/drawingml/2006/main" noGrp="1"/>
+          </p:cNvSpPr>
+          <p:nvPr/>
+        </p:nvSpPr>
+        <p:spPr>
+          <a:xfrm xmlns:a="http://schemas.openxmlformats.org/drawingml/2006/main">
+            <a:off x="6267450" y="2867025"/>
+            <a:ext cx="171450" cy="171450"/>
+          </a:xfrm>
+          <a:prstGeom xmlns:a="http://schemas.openxmlformats.org/drawingml/2006/main" prst="ellipse">
+            <a:avLst/>
+          </a:prstGeom>
+          <a:solidFill xmlns:a="http://schemas.openxmlformats.org/drawingml/2006/main">
+            <a:srgbClr val="000000"/>
+          </a:solidFill>
+          <a:ln xmlns:a="http://schemas.openxmlformats.org/drawingml/2006/main" w="0">
+            <a:solidFill>
+              <a:srgbClr val="000000"/>
+            </a:solidFill>
+            <a:prstDash val="solid"/>
+          </a:ln>
+        </p:spPr>
+      </p:sp>
+      <p:sp>
+        <p:nvSpPr>
+          <p:cNvPr id="14" name="pipeline-label-3">
+            <a:extLst xmlns:a="http://schemas.openxmlformats.org/drawingml/2006/main">
+              <a:ext uri="{FF2B5EF4-FFF2-40B4-BE49-F238E27FC236}">
+                <a16:creationId xmlns:a16="http://schemas.microsoft.com/office/drawing/2014/main" id="{061DF7D6-3142-4B04-9C3A-C0920EA58D79}"/>
+              </a:ext>
+            </a:extLst>
+          </p:cNvPr>
+          <p:cNvSpPr>
+            <a:spLocks xmlns:a="http://schemas.openxmlformats.org/drawingml/2006/main" noGrp="1"/>
+          </p:cNvSpPr>
+          <p:nvPr/>
+        </p:nvSpPr>
+        <p:spPr>
+          <a:xfrm xmlns:a="http://schemas.openxmlformats.org/drawingml/2006/main">
+            <a:off x="6267450" y="2381250"/>
+            <a:ext cx="2524125" cy="323850"/>
           </a:xfrm>
           <a:prstGeom xmlns:a="http://schemas.openxmlformats.org/drawingml/2006/main" prst="rect">
             <a:avLst/>
@@ -3370,47 +3891,47 @@
                 <a:spcPct val="100000"/>
               </a:lnSpc>
               <a:buNone/>
-              <a:defRPr sz="1950" b="1">
-                <a:solidFill>
-                  <a:srgbClr val="000000"/>
-                </a:solidFill>
-                <a:latin typeface="Arial"/>
-                <a:ea typeface="Arial"/>
-                <a:cs typeface="Arial"/>
-              </a:defRPr>
-            </a:pPr>
-            <a:r>
-              <a:rPr sz="1950" b="1">
-                <a:solidFill>
-                  <a:srgbClr val="000000"/>
-                </a:solidFill>
-                <a:latin typeface="Arial"/>
-                <a:ea typeface="Arial"/>
-                <a:cs typeface="Arial"/>
-              </a:rPr>
-              <a:t>Resolve local sense</a:t>
+              <a:defRPr sz="1350" b="1">
+                <a:solidFill>
+                  <a:srgbClr val="5B616B"/>
+                </a:solidFill>
+                <a:latin typeface="Arial"/>
+                <a:ea typeface="Arial"/>
+                <a:cs typeface="Arial"/>
+              </a:defRPr>
+            </a:pPr>
+            <a:r>
+              <a:rPr sz="1350" b="1">
+                <a:solidFill>
+                  <a:srgbClr val="5B616B"/>
+                </a:solidFill>
+                <a:latin typeface="Arial"/>
+                <a:ea typeface="Arial"/>
+                <a:cs typeface="Arial"/>
+              </a:rPr>
+              <a:t>03  ACTIVITY / CHANGE</a:t>
             </a:r>
           </a:p>
         </p:txBody>
       </p:sp>
       <p:sp>
         <p:nvSpPr>
-          <p:cNvPr id="12" name="pipeline-body-2">
-            <a:extLst xmlns:a="http://schemas.openxmlformats.org/drawingml/2006/main">
-              <a:ext uri="{FF2B5EF4-FFF2-40B4-BE49-F238E27FC236}">
-                <a16:creationId xmlns:a16="http://schemas.microsoft.com/office/drawing/2014/main" id="{3D7C48D8-6BB3-4AEB-BA68-C0D010F3A1EF}"/>
-              </a:ext>
-            </a:extLst>
-          </p:cNvPr>
-          <p:cNvSpPr>
-            <a:spLocks xmlns:a="http://schemas.openxmlformats.org/drawingml/2006/main" noGrp="1"/>
-          </p:cNvSpPr>
-          <p:nvPr/>
-        </p:nvSpPr>
-        <p:spPr>
-          <a:xfrm xmlns:a="http://schemas.openxmlformats.org/drawingml/2006/main">
-            <a:off x="3362325" y="3924300"/>
-            <a:ext cx="2524125" cy="1162050"/>
+          <p:cNvPr id="15" name="pipeline-title-3">
+            <a:extLst xmlns:a="http://schemas.openxmlformats.org/drawingml/2006/main">
+              <a:ext uri="{FF2B5EF4-FFF2-40B4-BE49-F238E27FC236}">
+                <a16:creationId xmlns:a16="http://schemas.microsoft.com/office/drawing/2014/main" id="{809860D1-A733-433F-84E1-784E9FDA9268}"/>
+              </a:ext>
+            </a:extLst>
+          </p:cNvPr>
+          <p:cNvSpPr>
+            <a:spLocks xmlns:a="http://schemas.openxmlformats.org/drawingml/2006/main" noGrp="1"/>
+          </p:cNvSpPr>
+          <p:nvPr/>
+        </p:nvSpPr>
+        <p:spPr>
+          <a:xfrm xmlns:a="http://schemas.openxmlformats.org/drawingml/2006/main">
+            <a:off x="6267450" y="3409950"/>
+            <a:ext cx="2524125" cy="361950"/>
           </a:xfrm>
           <a:prstGeom xmlns:a="http://schemas.openxmlformats.org/drawingml/2006/main" prst="rect">
             <a:avLst/>
@@ -3429,6 +3950,68 @@
           <a:p xmlns:a="http://schemas.openxmlformats.org/drawingml/2006/main">
             <a:pPr algn="l">
               <a:lnSpc>
+                <a:spcPct val="100000"/>
+              </a:lnSpc>
+              <a:buNone/>
+              <a:defRPr sz="1950" b="1">
+                <a:solidFill>
+                  <a:srgbClr val="000000"/>
+                </a:solidFill>
+                <a:latin typeface="Arial"/>
+                <a:ea typeface="Arial"/>
+                <a:cs typeface="Arial"/>
+              </a:defRPr>
+            </a:pPr>
+            <a:r>
+              <a:rPr sz="1950" b="1">
+                <a:solidFill>
+                  <a:srgbClr val="000000"/>
+                </a:solidFill>
+                <a:latin typeface="Arial"/>
+                <a:ea typeface="Arial"/>
+                <a:cs typeface="Arial"/>
+              </a:rPr>
+              <a:t>Start / stop / alter</a:t>
+            </a:r>
+          </a:p>
+        </p:txBody>
+      </p:sp>
+      <p:sp>
+        <p:nvSpPr>
+          <p:cNvPr id="16" name="pipeline-body-3">
+            <a:extLst xmlns:a="http://schemas.openxmlformats.org/drawingml/2006/main">
+              <a:ext uri="{FF2B5EF4-FFF2-40B4-BE49-F238E27FC236}">
+                <a16:creationId xmlns:a16="http://schemas.microsoft.com/office/drawing/2014/main" id="{DC5828E9-CFF1-4478-B212-9975ACE35BBE}"/>
+              </a:ext>
+            </a:extLst>
+          </p:cNvPr>
+          <p:cNvSpPr>
+            <a:spLocks xmlns:a="http://schemas.openxmlformats.org/drawingml/2006/main" noGrp="1"/>
+          </p:cNvSpPr>
+          <p:nvPr/>
+        </p:nvSpPr>
+        <p:spPr>
+          <a:xfrm xmlns:a="http://schemas.openxmlformats.org/drawingml/2006/main">
+            <a:off x="6267450" y="3876675"/>
+            <a:ext cx="2524125" cy="1504950"/>
+          </a:xfrm>
+          <a:prstGeom xmlns:a="http://schemas.openxmlformats.org/drawingml/2006/main" prst="rect">
+            <a:avLst/>
+          </a:prstGeom>
+          <a:noFill xmlns:a="http://schemas.openxmlformats.org/drawingml/2006/main"/>
+          <a:ln xmlns:a="http://schemas.openxmlformats.org/drawingml/2006/main" w="0">
+            <a:noFill/>
+            <a:prstDash val="solid"/>
+          </a:ln>
+        </p:spPr>
+        <p:txBody>
+          <a:bodyPr xmlns:a="http://schemas.openxmlformats.org/drawingml/2006/main" lIns="0" tIns="0" rIns="0" bIns="0" anchor="t">
+            <a:normAutofit fontScale="99521"/>
+          </a:bodyPr>
+          <a:lstStyle xmlns:a="http://schemas.openxmlformats.org/drawingml/2006/main"/>
+          <a:p xmlns:a="http://schemas.openxmlformats.org/drawingml/2006/main">
+            <a:pPr algn="l">
+              <a:lnSpc>
                 <a:spcPct val="105000"/>
               </a:lnSpc>
               <a:buNone/>
@@ -3442,47 +4025,209 @@
               </a:defRPr>
             </a:pPr>
             <a:r>
-              <a:rPr sz="1575" b="0">
-                <a:solidFill>
-                  <a:srgbClr val="5B616B"/>
-                </a:solidFill>
-                <a:latin typeface="Arial"/>
-                <a:ea typeface="Arial"/>
-                <a:cs typeface="Arial"/>
-              </a:rPr>
-              <a:t>Meet, file, set, rate, determine and employment use procedure-specific context.</a:t>
+              <a:rPr sz="1350" b="0">
+                <a:solidFill>
+                  <a:srgbClr val="5B616B"/>
+                </a:solidFill>
+                <a:latin typeface="Arial"/>
+                <a:ea typeface="Arial"/>
+                <a:cs typeface="Arial"/>
+              </a:rPr>
+              <a:t>Activity_finish</a:t>
+            </a:r>
+          </a:p>
+          <a:p xmlns:a="http://schemas.openxmlformats.org/drawingml/2006/main">
+            <a:pPr algn="l">
+              <a:lnSpc>
+                <a:spcPct val="105000"/>
+              </a:lnSpc>
+              <a:buNone/>
+              <a:defRPr sz="1575" b="0">
+                <a:solidFill>
+                  <a:srgbClr val="5B616B"/>
+                </a:solidFill>
+                <a:latin typeface="Arial"/>
+                <a:ea typeface="Arial"/>
+                <a:cs typeface="Arial"/>
+              </a:defRPr>
+            </a:pPr>
+            <a:r>
+              <a:rPr sz="1350" b="0">
+                <a:solidFill>
+                  <a:srgbClr val="5B616B"/>
+                </a:solidFill>
+                <a:latin typeface="Arial"/>
+                <a:ea typeface="Arial"/>
+                <a:cs typeface="Arial"/>
+              </a:rPr>
+              <a:t>Activity_resume</a:t>
+            </a:r>
+          </a:p>
+          <a:p xmlns:a="http://schemas.openxmlformats.org/drawingml/2006/main">
+            <a:pPr algn="l">
+              <a:lnSpc>
+                <a:spcPct val="105000"/>
+              </a:lnSpc>
+              <a:buNone/>
+              <a:defRPr sz="1575" b="0">
+                <a:solidFill>
+                  <a:srgbClr val="5B616B"/>
+                </a:solidFill>
+                <a:latin typeface="Arial"/>
+                <a:ea typeface="Arial"/>
+                <a:cs typeface="Arial"/>
+              </a:defRPr>
+            </a:pPr>
+            <a:r>
+              <a:rPr sz="1350" b="0">
+                <a:solidFill>
+                  <a:srgbClr val="5B616B"/>
+                </a:solidFill>
+                <a:latin typeface="Arial"/>
+                <a:ea typeface="Arial"/>
+                <a:cs typeface="Arial"/>
+              </a:rPr>
+              <a:t>Activity_stop</a:t>
+            </a:r>
+          </a:p>
+          <a:p xmlns:a="http://schemas.openxmlformats.org/drawingml/2006/main">
+            <a:pPr algn="l">
+              <a:lnSpc>
+                <a:spcPct val="105000"/>
+              </a:lnSpc>
+              <a:buNone/>
+              <a:defRPr sz="1575" b="0">
+                <a:solidFill>
+                  <a:srgbClr val="5B616B"/>
+                </a:solidFill>
+                <a:latin typeface="Arial"/>
+                <a:ea typeface="Arial"/>
+                <a:cs typeface="Arial"/>
+              </a:defRPr>
+            </a:pPr>
+            <a:r>
+              <a:rPr sz="1350" b="0">
+                <a:solidFill>
+                  <a:srgbClr val="5B616B"/>
+                </a:solidFill>
+                <a:latin typeface="Arial"/>
+                <a:ea typeface="Arial"/>
+                <a:cs typeface="Arial"/>
+              </a:rPr>
+              <a:t>Cause_to_start</a:t>
+            </a:r>
+          </a:p>
+          <a:p xmlns:a="http://schemas.openxmlformats.org/drawingml/2006/main">
+            <a:pPr algn="l">
+              <a:lnSpc>
+                <a:spcPct val="105000"/>
+              </a:lnSpc>
+              <a:buNone/>
+              <a:defRPr sz="1575" b="0">
+                <a:solidFill>
+                  <a:srgbClr val="5B616B"/>
+                </a:solidFill>
+                <a:latin typeface="Arial"/>
+                <a:ea typeface="Arial"/>
+                <a:cs typeface="Arial"/>
+              </a:defRPr>
+            </a:pPr>
+            <a:r>
+              <a:rPr sz="1350" b="0">
+                <a:solidFill>
+                  <a:srgbClr val="5B616B"/>
+                </a:solidFill>
+                <a:latin typeface="Arial"/>
+                <a:ea typeface="Arial"/>
+                <a:cs typeface="Arial"/>
+              </a:rPr>
+              <a:t>Cause_change</a:t>
+            </a:r>
+          </a:p>
+          <a:p xmlns:a="http://schemas.openxmlformats.org/drawingml/2006/main">
+            <a:pPr algn="l">
+              <a:lnSpc>
+                <a:spcPct val="105000"/>
+              </a:lnSpc>
+              <a:buNone/>
+              <a:defRPr sz="1575" b="0">
+                <a:solidFill>
+                  <a:srgbClr val="5B616B"/>
+                </a:solidFill>
+                <a:latin typeface="Arial"/>
+                <a:ea typeface="Arial"/>
+                <a:cs typeface="Arial"/>
+              </a:defRPr>
+            </a:pPr>
+            <a:r>
+              <a:rPr sz="1350" b="0">
+                <a:solidFill>
+                  <a:srgbClr val="5B616B"/>
+                </a:solidFill>
+                <a:latin typeface="Arial"/>
+                <a:ea typeface="Arial"/>
+                <a:cs typeface="Arial"/>
+              </a:rPr>
+              <a:t>Replacing</a:t>
+            </a:r>
+          </a:p>
+          <a:p xmlns:a="http://schemas.openxmlformats.org/drawingml/2006/main">
+            <a:pPr algn="l">
+              <a:lnSpc>
+                <a:spcPct val="105000"/>
+              </a:lnSpc>
+              <a:buNone/>
+              <a:defRPr sz="1575" b="0">
+                <a:solidFill>
+                  <a:srgbClr val="5B616B"/>
+                </a:solidFill>
+                <a:latin typeface="Arial"/>
+                <a:ea typeface="Arial"/>
+                <a:cs typeface="Arial"/>
+              </a:defRPr>
+            </a:pPr>
+            <a:r>
+              <a:rPr sz="1350" b="0">
+                <a:solidFill>
+                  <a:srgbClr val="5B616B"/>
+                </a:solidFill>
+                <a:latin typeface="Arial"/>
+                <a:ea typeface="Arial"/>
+                <a:cs typeface="Arial"/>
+              </a:rPr>
+              <a:t>Resolve_problem</a:t>
             </a:r>
           </a:p>
         </p:txBody>
       </p:sp>
       <p:sp>
         <p:nvSpPr>
-          <p:cNvPr id="13" name="pipeline-dot-3">
-            <a:extLst xmlns:a="http://schemas.openxmlformats.org/drawingml/2006/main">
-              <a:ext uri="{FF2B5EF4-FFF2-40B4-BE49-F238E27FC236}">
-                <a16:creationId xmlns:a16="http://schemas.microsoft.com/office/drawing/2014/main" id="{8034CDC0-BDF0-499C-AF72-11E63E200821}"/>
-              </a:ext>
-            </a:extLst>
-          </p:cNvPr>
-          <p:cNvSpPr>
-            <a:spLocks xmlns:a="http://schemas.openxmlformats.org/drawingml/2006/main" noGrp="1"/>
-          </p:cNvSpPr>
-          <p:nvPr/>
-        </p:nvSpPr>
-        <p:spPr>
-          <a:xfrm xmlns:a="http://schemas.openxmlformats.org/drawingml/2006/main">
-            <a:off x="6267450" y="2867025"/>
+          <p:cNvPr id="17" name="pipeline-dot-4">
+            <a:extLst xmlns:a="http://schemas.openxmlformats.org/drawingml/2006/main">
+              <a:ext uri="{FF2B5EF4-FFF2-40B4-BE49-F238E27FC236}">
+                <a16:creationId xmlns:a16="http://schemas.microsoft.com/office/drawing/2014/main" id="{1203CB3A-5C57-435A-BC51-315D29005969}"/>
+              </a:ext>
+            </a:extLst>
+          </p:cNvPr>
+          <p:cNvSpPr>
+            <a:spLocks xmlns:a="http://schemas.openxmlformats.org/drawingml/2006/main" noGrp="1"/>
+          </p:cNvSpPr>
+          <p:nvPr/>
+        </p:nvSpPr>
+        <p:spPr>
+          <a:xfrm xmlns:a="http://schemas.openxmlformats.org/drawingml/2006/main">
+            <a:off x="9172575" y="2867025"/>
             <a:ext cx="171450" cy="171450"/>
           </a:xfrm>
           <a:prstGeom xmlns:a="http://schemas.openxmlformats.org/drawingml/2006/main" prst="ellipse">
             <a:avLst/>
           </a:prstGeom>
           <a:solidFill xmlns:a="http://schemas.openxmlformats.org/drawingml/2006/main">
-            <a:srgbClr val="000000"/>
+            <a:srgbClr val="3D8DFF"/>
           </a:solidFill>
           <a:ln xmlns:a="http://schemas.openxmlformats.org/drawingml/2006/main" w="0">
             <a:solidFill>
-              <a:srgbClr val="000000"/>
+              <a:srgbClr val="3D8DFF"/>
             </a:solidFill>
             <a:prstDash val="solid"/>
           </a:ln>
@@ -3490,21 +4235,21 @@
       </p:sp>
       <p:sp>
         <p:nvSpPr>
-          <p:cNvPr id="14" name="pipeline-label-3">
-            <a:extLst xmlns:a="http://schemas.openxmlformats.org/drawingml/2006/main">
-              <a:ext uri="{FF2B5EF4-FFF2-40B4-BE49-F238E27FC236}">
-                <a16:creationId xmlns:a16="http://schemas.microsoft.com/office/drawing/2014/main" id="{061DF7D6-3142-4B04-9C3A-C0920EA58D79}"/>
-              </a:ext>
-            </a:extLst>
-          </p:cNvPr>
-          <p:cNvSpPr>
-            <a:spLocks xmlns:a="http://schemas.openxmlformats.org/drawingml/2006/main" noGrp="1"/>
-          </p:cNvSpPr>
-          <p:nvPr/>
-        </p:nvSpPr>
-        <p:spPr>
-          <a:xfrm xmlns:a="http://schemas.openxmlformats.org/drawingml/2006/main">
-            <a:off x="6267450" y="2381250"/>
+          <p:cNvPr id="18" name="pipeline-label-4">
+            <a:extLst xmlns:a="http://schemas.openxmlformats.org/drawingml/2006/main">
+              <a:ext uri="{FF2B5EF4-FFF2-40B4-BE49-F238E27FC236}">
+                <a16:creationId xmlns:a16="http://schemas.microsoft.com/office/drawing/2014/main" id="{C11384F0-4CEF-4EFB-A4AA-54802107E922}"/>
+              </a:ext>
+            </a:extLst>
+          </p:cNvPr>
+          <p:cNvSpPr>
+            <a:spLocks xmlns:a="http://schemas.openxmlformats.org/drawingml/2006/main" noGrp="1"/>
+          </p:cNvSpPr>
+          <p:nvPr/>
+        </p:nvSpPr>
+        <p:spPr>
+          <a:xfrm xmlns:a="http://schemas.openxmlformats.org/drawingml/2006/main">
+            <a:off x="9172575" y="2381250"/>
             <a:ext cx="2524125" cy="323850"/>
           </a:xfrm>
           <a:prstGeom xmlns:a="http://schemas.openxmlformats.org/drawingml/2006/main" prst="rect">
@@ -3529,7 +4274,7 @@
               <a:buNone/>
               <a:defRPr sz="1350" b="1">
                 <a:solidFill>
-                  <a:srgbClr val="5B616B"/>
+                  <a:srgbClr val="3D8DFF"/>
                 </a:solidFill>
                 <a:latin typeface="Arial"/>
                 <a:ea typeface="Arial"/>
@@ -3539,34 +4284,34 @@
             <a:r>
               <a:rPr sz="1350" b="1">
                 <a:solidFill>
-                  <a:srgbClr val="5B616B"/>
-                </a:solidFill>
-                <a:latin typeface="Arial"/>
-                <a:ea typeface="Arial"/>
-                <a:cs typeface="Arial"/>
-              </a:rPr>
-              <a:t>03  ROLE GUARDRAILS</a:t>
+                  <a:srgbClr val="3D8DFF"/>
+                </a:solidFill>
+                <a:latin typeface="Arial"/>
+                <a:ea typeface="Arial"/>
+                <a:cs typeface="Arial"/>
+              </a:rPr>
+              <a:t>04  AGREEMENT / WORK</a:t>
             </a:r>
           </a:p>
         </p:txBody>
       </p:sp>
       <p:sp>
         <p:nvSpPr>
-          <p:cNvPr id="15" name="pipeline-title-3">
-            <a:extLst xmlns:a="http://schemas.openxmlformats.org/drawingml/2006/main">
-              <a:ext uri="{FF2B5EF4-FFF2-40B4-BE49-F238E27FC236}">
-                <a16:creationId xmlns:a16="http://schemas.microsoft.com/office/drawing/2014/main" id="{809860D1-A733-433F-84E1-784E9FDA9268}"/>
-              </a:ext>
-            </a:extLst>
-          </p:cNvPr>
-          <p:cNvSpPr>
-            <a:spLocks xmlns:a="http://schemas.openxmlformats.org/drawingml/2006/main" noGrp="1"/>
-          </p:cNvSpPr>
-          <p:nvPr/>
-        </p:nvSpPr>
-        <p:spPr>
-          <a:xfrm xmlns:a="http://schemas.openxmlformats.org/drawingml/2006/main">
-            <a:off x="6267450" y="3409950"/>
+          <p:cNvPr id="19" name="pipeline-title-4">
+            <a:extLst xmlns:a="http://schemas.openxmlformats.org/drawingml/2006/main">
+              <a:ext uri="{FF2B5EF4-FFF2-40B4-BE49-F238E27FC236}">
+                <a16:creationId xmlns:a16="http://schemas.microsoft.com/office/drawing/2014/main" id="{E8230EE8-2A38-412D-AB58-26CD5CE13223}"/>
+              </a:ext>
+            </a:extLst>
+          </p:cNvPr>
+          <p:cNvSpPr>
+            <a:spLocks xmlns:a="http://schemas.openxmlformats.org/drawingml/2006/main" noGrp="1"/>
+          </p:cNvSpPr>
+          <p:nvPr/>
+        </p:nvSpPr>
+        <p:spPr>
+          <a:xfrm xmlns:a="http://schemas.openxmlformats.org/drawingml/2006/main">
+            <a:off x="9172575" y="3409950"/>
             <a:ext cx="2524125" cy="361950"/>
           </a:xfrm>
           <a:prstGeom xmlns:a="http://schemas.openxmlformats.org/drawingml/2006/main" prst="rect">
@@ -3607,29 +4352,29 @@
                 <a:ea typeface="Arial"/>
                 <a:cs typeface="Arial"/>
               </a:rPr>
-              <a:t>Reject irrelevant FEs</a:t>
+              <a:t>Agree / work / submit</a:t>
             </a:r>
           </a:p>
         </p:txBody>
       </p:sp>
       <p:sp>
         <p:nvSpPr>
-          <p:cNvPr id="16" name="pipeline-body-3">
-            <a:extLst xmlns:a="http://schemas.openxmlformats.org/drawingml/2006/main">
-              <a:ext uri="{FF2B5EF4-FFF2-40B4-BE49-F238E27FC236}">
-                <a16:creationId xmlns:a16="http://schemas.microsoft.com/office/drawing/2014/main" id="{DC5828E9-CFF1-4478-B212-9975ACE35BBE}"/>
-              </a:ext>
-            </a:extLst>
-          </p:cNvPr>
-          <p:cNvSpPr>
-            <a:spLocks xmlns:a="http://schemas.openxmlformats.org/drawingml/2006/main" noGrp="1"/>
-          </p:cNvSpPr>
-          <p:nvPr/>
-        </p:nvSpPr>
-        <p:spPr>
-          <a:xfrm xmlns:a="http://schemas.openxmlformats.org/drawingml/2006/main">
-            <a:off x="6267450" y="3924300"/>
-            <a:ext cx="2524125" cy="1162050"/>
+          <p:cNvPr id="20" name="pipeline-body-4">
+            <a:extLst xmlns:a="http://schemas.openxmlformats.org/drawingml/2006/main">
+              <a:ext uri="{FF2B5EF4-FFF2-40B4-BE49-F238E27FC236}">
+                <a16:creationId xmlns:a16="http://schemas.microsoft.com/office/drawing/2014/main" id="{028C5188-508B-48F3-86DB-02BD2404B29A}"/>
+              </a:ext>
+            </a:extLst>
+          </p:cNvPr>
+          <p:cNvSpPr>
+            <a:spLocks xmlns:a="http://schemas.openxmlformats.org/drawingml/2006/main" noGrp="1"/>
+          </p:cNvSpPr>
+          <p:nvPr/>
+        </p:nvSpPr>
+        <p:spPr>
+          <a:xfrm xmlns:a="http://schemas.openxmlformats.org/drawingml/2006/main">
+            <a:off x="9172575" y="3876675"/>
+            <a:ext cx="2524125" cy="1504950"/>
           </a:xfrm>
           <a:prstGeom xmlns:a="http://schemas.openxmlformats.org/drawingml/2006/main" prst="rect">
             <a:avLst/>
@@ -3661,209 +4406,71 @@
               </a:defRPr>
             </a:pPr>
             <a:r>
-              <a:rPr sz="1575" b="0">
-                <a:solidFill>
-                  <a:srgbClr val="5B616B"/>
-                </a:solidFill>
-                <a:latin typeface="Arial"/>
-                <a:ea typeface="Arial"/>
-                <a:cs typeface="Arial"/>
-              </a:rPr>
-              <a:t>False senses are suppressed; quantities and record labels become structured knowledge.</a:t>
-            </a:r>
-          </a:p>
-        </p:txBody>
-      </p:sp>
-      <p:sp>
-        <p:nvSpPr>
-          <p:cNvPr id="17" name="pipeline-dot-4">
-            <a:extLst xmlns:a="http://schemas.openxmlformats.org/drawingml/2006/main">
-              <a:ext uri="{FF2B5EF4-FFF2-40B4-BE49-F238E27FC236}">
-                <a16:creationId xmlns:a16="http://schemas.microsoft.com/office/drawing/2014/main" id="{1203CB3A-5C57-435A-BC51-315D29005969}"/>
-              </a:ext>
-            </a:extLst>
-          </p:cNvPr>
-          <p:cNvSpPr>
-            <a:spLocks xmlns:a="http://schemas.openxmlformats.org/drawingml/2006/main" noGrp="1"/>
-          </p:cNvSpPr>
-          <p:nvPr/>
-        </p:nvSpPr>
-        <p:spPr>
-          <a:xfrm xmlns:a="http://schemas.openxmlformats.org/drawingml/2006/main">
-            <a:off x="9172575" y="2867025"/>
-            <a:ext cx="171450" cy="171450"/>
-          </a:xfrm>
-          <a:prstGeom xmlns:a="http://schemas.openxmlformats.org/drawingml/2006/main" prst="ellipse">
-            <a:avLst/>
-          </a:prstGeom>
-          <a:solidFill xmlns:a="http://schemas.openxmlformats.org/drawingml/2006/main">
-            <a:srgbClr val="3D8DFF"/>
-          </a:solidFill>
-          <a:ln xmlns:a="http://schemas.openxmlformats.org/drawingml/2006/main" w="0">
-            <a:solidFill>
-              <a:srgbClr val="3D8DFF"/>
-            </a:solidFill>
-            <a:prstDash val="solid"/>
-          </a:ln>
-        </p:spPr>
-      </p:sp>
-      <p:sp>
-        <p:nvSpPr>
-          <p:cNvPr id="18" name="pipeline-label-4">
-            <a:extLst xmlns:a="http://schemas.openxmlformats.org/drawingml/2006/main">
-              <a:ext uri="{FF2B5EF4-FFF2-40B4-BE49-F238E27FC236}">
-                <a16:creationId xmlns:a16="http://schemas.microsoft.com/office/drawing/2014/main" id="{C11384F0-4CEF-4EFB-A4AA-54802107E922}"/>
-              </a:ext>
-            </a:extLst>
-          </p:cNvPr>
-          <p:cNvSpPr>
-            <a:spLocks xmlns:a="http://schemas.openxmlformats.org/drawingml/2006/main" noGrp="1"/>
-          </p:cNvSpPr>
-          <p:nvPr/>
-        </p:nvSpPr>
-        <p:spPr>
-          <a:xfrm xmlns:a="http://schemas.openxmlformats.org/drawingml/2006/main">
-            <a:off x="9172575" y="2381250"/>
-            <a:ext cx="2524125" cy="323850"/>
-          </a:xfrm>
-          <a:prstGeom xmlns:a="http://schemas.openxmlformats.org/drawingml/2006/main" prst="rect">
-            <a:avLst/>
-          </a:prstGeom>
-          <a:noFill xmlns:a="http://schemas.openxmlformats.org/drawingml/2006/main"/>
-          <a:ln xmlns:a="http://schemas.openxmlformats.org/drawingml/2006/main" w="0">
-            <a:noFill/>
-            <a:prstDash val="solid"/>
-          </a:ln>
-        </p:spPr>
-        <p:txBody>
-          <a:bodyPr xmlns:a="http://schemas.openxmlformats.org/drawingml/2006/main" lIns="0" tIns="0" rIns="0" bIns="0" anchor="t">
-            <a:normAutofit fontScale="100000"/>
-          </a:bodyPr>
-          <a:lstStyle xmlns:a="http://schemas.openxmlformats.org/drawingml/2006/main"/>
+              <a:rPr sz="1350" b="0">
+                <a:solidFill>
+                  <a:srgbClr val="5B616B"/>
+                </a:solidFill>
+                <a:latin typeface="Arial"/>
+                <a:ea typeface="Arial"/>
+                <a:cs typeface="Arial"/>
+              </a:rPr>
+              <a:t>Make_agreement_on_action</a:t>
+            </a:r>
+          </a:p>
           <a:p xmlns:a="http://schemas.openxmlformats.org/drawingml/2006/main">
             <a:pPr algn="l">
               <a:lnSpc>
-                <a:spcPct val="100000"/>
-              </a:lnSpc>
-              <a:buNone/>
-              <a:defRPr sz="1350" b="1">
-                <a:solidFill>
-                  <a:srgbClr val="3D8DFF"/>
-                </a:solidFill>
-                <a:latin typeface="Arial"/>
-                <a:ea typeface="Arial"/>
-                <a:cs typeface="Arial"/>
-              </a:defRPr>
-            </a:pPr>
-            <a:r>
-              <a:rPr sz="1350" b="1">
-                <a:solidFill>
-                  <a:srgbClr val="3D8DFF"/>
-                </a:solidFill>
-                <a:latin typeface="Arial"/>
-                <a:ea typeface="Arial"/>
-                <a:cs typeface="Arial"/>
-              </a:rPr>
-              <a:t>04  DISPOSITION</a:t>
-            </a:r>
-          </a:p>
-        </p:txBody>
-      </p:sp>
-      <p:sp>
-        <p:nvSpPr>
-          <p:cNvPr id="19" name="pipeline-title-4">
-            <a:extLst xmlns:a="http://schemas.openxmlformats.org/drawingml/2006/main">
-              <a:ext uri="{FF2B5EF4-FFF2-40B4-BE49-F238E27FC236}">
-                <a16:creationId xmlns:a16="http://schemas.microsoft.com/office/drawing/2014/main" id="{E8230EE8-2A38-412D-AB58-26CD5CE13223}"/>
-              </a:ext>
-            </a:extLst>
-          </p:cNvPr>
-          <p:cNvSpPr>
-            <a:spLocks xmlns:a="http://schemas.openxmlformats.org/drawingml/2006/main" noGrp="1"/>
-          </p:cNvSpPr>
-          <p:nvPr/>
-        </p:nvSpPr>
-        <p:spPr>
-          <a:xfrm xmlns:a="http://schemas.openxmlformats.org/drawingml/2006/main">
-            <a:off x="9172575" y="3409950"/>
-            <a:ext cx="2524125" cy="361950"/>
-          </a:xfrm>
-          <a:prstGeom xmlns:a="http://schemas.openxmlformats.org/drawingml/2006/main" prst="rect">
-            <a:avLst/>
-          </a:prstGeom>
-          <a:noFill xmlns:a="http://schemas.openxmlformats.org/drawingml/2006/main"/>
-          <a:ln xmlns:a="http://schemas.openxmlformats.org/drawingml/2006/main" w="0">
-            <a:noFill/>
-            <a:prstDash val="solid"/>
-          </a:ln>
-        </p:spPr>
-        <p:txBody>
-          <a:bodyPr xmlns:a="http://schemas.openxmlformats.org/drawingml/2006/main" lIns="0" tIns="0" rIns="0" bIns="0" anchor="t">
-            <a:normAutofit fontScale="93417"/>
-          </a:bodyPr>
-          <a:lstStyle xmlns:a="http://schemas.openxmlformats.org/drawingml/2006/main"/>
+                <a:spcPct val="105000"/>
+              </a:lnSpc>
+              <a:buNone/>
+              <a:defRPr sz="1575" b="0">
+                <a:solidFill>
+                  <a:srgbClr val="5B616B"/>
+                </a:solidFill>
+                <a:latin typeface="Arial"/>
+                <a:ea typeface="Arial"/>
+                <a:cs typeface="Arial"/>
+              </a:defRPr>
+            </a:pPr>
+            <a:r>
+              <a:rPr sz="1350" b="0">
+                <a:solidFill>
+                  <a:srgbClr val="5B616B"/>
+                </a:solidFill>
+                <a:latin typeface="Arial"/>
+                <a:ea typeface="Arial"/>
+                <a:cs typeface="Arial"/>
+              </a:rPr>
+              <a:t>Be_in_agreement_on_action</a:t>
+            </a:r>
+          </a:p>
           <a:p xmlns:a="http://schemas.openxmlformats.org/drawingml/2006/main">
             <a:pPr algn="l">
               <a:lnSpc>
-                <a:spcPct val="100000"/>
-              </a:lnSpc>
-              <a:buNone/>
-              <a:defRPr sz="1950" b="1">
-                <a:solidFill>
-                  <a:srgbClr val="000000"/>
-                </a:solidFill>
-                <a:latin typeface="Arial"/>
-                <a:ea typeface="Arial"/>
-                <a:cs typeface="Arial"/>
-              </a:defRPr>
-            </a:pPr>
-            <a:r>
-              <a:rPr sz="1950" b="1">
-                <a:solidFill>
-                  <a:srgbClr val="000000"/>
-                </a:solidFill>
-                <a:latin typeface="Arial"/>
-                <a:ea typeface="Arial"/>
-                <a:cs typeface="Arial"/>
-              </a:rPr>
-              <a:t>Do not force ambiguity</a:t>
-            </a:r>
-          </a:p>
-        </p:txBody>
-      </p:sp>
-      <p:sp>
-        <p:nvSpPr>
-          <p:cNvPr id="20" name="pipeline-body-4">
-            <a:extLst xmlns:a="http://schemas.openxmlformats.org/drawingml/2006/main">
-              <a:ext uri="{FF2B5EF4-FFF2-40B4-BE49-F238E27FC236}">
-                <a16:creationId xmlns:a16="http://schemas.microsoft.com/office/drawing/2014/main" id="{028C5188-508B-48F3-86DB-02BD2404B29A}"/>
-              </a:ext>
-            </a:extLst>
-          </p:cNvPr>
-          <p:cNvSpPr>
-            <a:spLocks xmlns:a="http://schemas.openxmlformats.org/drawingml/2006/main" noGrp="1"/>
-          </p:cNvSpPr>
-          <p:nvPr/>
-        </p:nvSpPr>
-        <p:spPr>
-          <a:xfrm xmlns:a="http://schemas.openxmlformats.org/drawingml/2006/main">
-            <a:off x="9172575" y="3924300"/>
-            <a:ext cx="2524125" cy="1162050"/>
-          </a:xfrm>
-          <a:prstGeom xmlns:a="http://schemas.openxmlformats.org/drawingml/2006/main" prst="rect">
-            <a:avLst/>
-          </a:prstGeom>
-          <a:noFill xmlns:a="http://schemas.openxmlformats.org/drawingml/2006/main"/>
-          <a:ln xmlns:a="http://schemas.openxmlformats.org/drawingml/2006/main" w="0">
-            <a:noFill/>
-            <a:prstDash val="solid"/>
-          </a:ln>
-        </p:spPr>
-        <p:txBody>
-          <a:bodyPr xmlns:a="http://schemas.openxmlformats.org/drawingml/2006/main" lIns="0" tIns="0" rIns="0" bIns="0" anchor="t">
-            <a:normAutofit fontScale="100000"/>
-          </a:bodyPr>
-          <a:lstStyle xmlns:a="http://schemas.openxmlformats.org/drawingml/2006/main"/>
+                <a:spcPct val="105000"/>
+              </a:lnSpc>
+              <a:buNone/>
+              <a:defRPr sz="1575" b="0">
+                <a:solidFill>
+                  <a:srgbClr val="5B616B"/>
+                </a:solidFill>
+                <a:latin typeface="Arial"/>
+                <a:ea typeface="Arial"/>
+                <a:cs typeface="Arial"/>
+              </a:defRPr>
+            </a:pPr>
+            <a:r>
+              <a:rPr sz="1350" b="0">
+                <a:solidFill>
+                  <a:srgbClr val="5B616B"/>
+                </a:solidFill>
+                <a:latin typeface="Arial"/>
+                <a:ea typeface="Arial"/>
+                <a:cs typeface="Arial"/>
+              </a:rPr>
+              <a:t>Being_employed</a:t>
+            </a:r>
+          </a:p>
           <a:p xmlns:a="http://schemas.openxmlformats.org/drawingml/2006/main">
             <a:pPr algn="l">
               <a:lnSpc>
@@ -3880,15 +4487,42 @@
               </a:defRPr>
             </a:pPr>
             <a:r>
-              <a:rPr sz="1575" b="0">
-                <a:solidFill>
-                  <a:srgbClr val="5B616B"/>
-                </a:solidFill>
-                <a:latin typeface="Arial"/>
-                <a:ea typeface="Arial"/>
-                <a:cs typeface="Arial"/>
-              </a:rPr>
-              <a:t>Canonical, structured, review, no-domain and artifact outcomes stay distinct.</a:t>
+              <a:rPr sz="1350" b="0">
+                <a:solidFill>
+                  <a:srgbClr val="5B616B"/>
+                </a:solidFill>
+                <a:latin typeface="Arial"/>
+                <a:ea typeface="Arial"/>
+                <a:cs typeface="Arial"/>
+              </a:rPr>
+              <a:t>Submitting_documents</a:t>
+            </a:r>
+          </a:p>
+          <a:p xmlns:a="http://schemas.openxmlformats.org/drawingml/2006/main">
+            <a:pPr algn="l">
+              <a:lnSpc>
+                <a:spcPct val="105000"/>
+              </a:lnSpc>
+              <a:buNone/>
+              <a:defRPr sz="1575" b="0">
+                <a:solidFill>
+                  <a:srgbClr val="5B616B"/>
+                </a:solidFill>
+                <a:latin typeface="Arial"/>
+                <a:ea typeface="Arial"/>
+                <a:cs typeface="Arial"/>
+              </a:defRPr>
+            </a:pPr>
+            <a:r>
+              <a:rPr sz="1350" b="0">
+                <a:solidFill>
+                  <a:srgbClr val="5B616B"/>
+                </a:solidFill>
+                <a:latin typeface="Arial"/>
+                <a:ea typeface="Arial"/>
+                <a:cs typeface="Arial"/>
+              </a:rPr>
+              <a:t>Rewards_and_punishments</a:t>
             </a:r>
           </a:p>
         </p:txBody>
@@ -3956,7 +4590,7 @@
         </p:spPr>
         <p:txBody>
           <a:bodyPr xmlns:a="http://schemas.openxmlformats.org/drawingml/2006/main" lIns="0" tIns="0" rIns="0" bIns="0" anchor="t">
-            <a:normAutofit fontScale="91139"/>
+            <a:normAutofit fontScale="83661"/>
           </a:bodyPr>
           <a:lstStyle xmlns:a="http://schemas.openxmlformats.org/drawingml/2006/main"/>
           <a:p xmlns:a="http://schemas.openxmlformats.org/drawingml/2006/main">
@@ -3983,7 +4617,7 @@
                 <a:ea typeface="Arial"/>
                 <a:cs typeface="Arial"/>
               </a:rPr>
-              <a:t>Precision rule: only high-confidence canonical or structured outcomes are automatic; everything else stays inspectable.</a:t>
+              <a:t>26 approved in procedure-domain-v1 • Replacing is unobserved • raw candidates, suppressions and review routes remain traceable</a:t>
             </a:r>
           </a:p>
         </p:txBody>
@@ -4047,7 +4681,7 @@
         </p:spPr>
         <p:txBody>
           <a:bodyPr xmlns:a="http://schemas.openxmlformats.org/drawingml/2006/main" lIns="0" tIns="0" rIns="0" bIns="0" anchor="t">
-            <a:normAutofit fontScale="90438"/>
+            <a:normAutofit fontScale="100000"/>
           </a:bodyPr>
           <a:lstStyle xmlns:a="http://schemas.openxmlformats.org/drawingml/2006/main"/>
           <a:p xmlns:a="http://schemas.openxmlformats.org/drawingml/2006/main">
@@ -4074,7 +4708,7 @@
                 <a:ea typeface="Arial"/>
                 <a:cs typeface="Arial"/>
               </a:rPr>
-              <a:t>The retained inventory is concentrated in procedural actions</a:t>
+              <a:t>High-volume rules define the validation priority</a:t>
             </a:r>
           </a:p>
         </p:txBody>
@@ -4136,7 +4770,7 @@
                 <a:ea typeface="Arial"/>
                 <a:cs typeface="Arial"/>
               </a:rPr>
-              <a:t>Top canonical frames by sentence occurrence; a sentence may retain more than one canonical frame.</a:t>
+              <a:t>Obligation matches come from explicit must / shall / required-to patterns; concentration may be domain-real or rule-driven.</a:t>
             </a:r>
           </a:p>
         </p:txBody>
@@ -4238,7 +4872,7 @@
       </p:sp>
       <p:graphicFrame>
         <p:nvGraphicFramePr>
-          <p:cNvPr id="16" name="Chart"/>
+          <p:cNvPr id="18" name="Chart"/>
           <p:cNvGraphicFramePr/>
           <p:nvPr/>
         </p:nvGraphicFramePr>
@@ -4248,7 +4882,7 @@
         </p:xfrm>
         <a:graphic xmlns:a="http://schemas.openxmlformats.org/drawingml/2006/main">
           <a:graphicData uri="http://schemas.openxmlformats.org/drawingml/2006/chart">
-            <c:chart xmlns:r="http://schemas.openxmlformats.org/officeDocument/2006/relationships" xmlns:c="http://schemas.openxmlformats.org/drawingml/2006/chart" r:id="R1393f11c456b4809"/>
+            <c:chart xmlns:r="http://schemas.openxmlformats.org/officeDocument/2006/relationships" xmlns:c="http://schemas.openxmlformats.org/drawingml/2006/chart" r:id="R11c96e1ff10840a1"/>
           </a:graphicData>
         </a:graphic>
       </p:graphicFrame>
@@ -4342,7 +4976,7 @@
                 <a:ea typeface="Arial"/>
                 <a:cs typeface="Arial"/>
               </a:rPr>
-              <a:t>4,233</a:t>
+              <a:t>22.5%</a:t>
             </a:r>
           </a:p>
         </p:txBody>
@@ -4377,7 +5011,7 @@
         </p:spPr>
         <p:txBody>
           <a:bodyPr xmlns:a="http://schemas.openxmlformats.org/drawingml/2006/main" lIns="0" tIns="0" rIns="0" bIns="0" anchor="t">
-            <a:normAutofit fontScale="92021"/>
+            <a:normAutofit fontScale="84656"/>
           </a:bodyPr>
           <a:lstStyle xmlns:a="http://schemas.openxmlformats.org/drawingml/2006/main"/>
           <a:p xmlns:a="http://schemas.openxmlformats.org/drawingml/2006/main">
@@ -4404,7 +5038,7 @@
                 <a:ea typeface="Arial"/>
                 <a:cs typeface="Arial"/>
               </a:rPr>
-              <a:t>sentences express an explicit procedural obligation—the largest retained frame.</a:t>
+              <a:t>of 18,785 assignments are Imposing_obligation. Plausible for procedures—but audit for overreach.</a:t>
             </a:r>
           </a:p>
         </p:txBody>
@@ -4499,7 +5133,7 @@
                 <a:ea typeface="Arial"/>
                 <a:cs typeface="Arial"/>
               </a:rPr>
-              <a:t>50.1%</a:t>
+              <a:t>5,700</a:t>
             </a:r>
           </a:p>
         </p:txBody>
@@ -4561,7 +5195,7 @@
                 <a:ea typeface="Arial"/>
                 <a:cs typeface="Arial"/>
               </a:rPr>
-              <a:t>of all 18,785 canonical assignments come from the top four frames: obligation, request, deciding and evidence.</a:t>
+              <a:t>sentences need human handling: 4,075 review + 1,625 no-domain. Time a 100-item pilot before staffing.</a:t>
             </a:r>
           </a:p>
         </p:txBody>
@@ -4625,7 +5259,7 @@
         </p:spPr>
         <p:txBody>
           <a:bodyPr xmlns:a="http://schemas.openxmlformats.org/drawingml/2006/main" lIns="0" tIns="0" rIns="0" bIns="0" anchor="t">
-            <a:normAutofit fontScale="68729"/>
+            <a:normAutofit fontScale="83029"/>
           </a:bodyPr>
           <a:lstStyle xmlns:a="http://schemas.openxmlformats.org/drawingml/2006/main"/>
           <a:p xmlns:a="http://schemas.openxmlformats.org/drawingml/2006/main">
@@ -4652,7 +5286,7 @@
                 <a:ea typeface="Arial"/>
                 <a:cs typeface="Arial"/>
               </a:rPr>
-              <a:t>Irrelevant frame elements came from lexical collisions—not procedure meaning</a:t>
+              <a:t>Examples show what the rules change—and what they do not test</a:t>
             </a:r>
           </a:p>
         </p:txBody>
@@ -4714,7 +5348,7 @@
                 <a:ea typeface="Arial"/>
                 <a:cs typeface="Arial"/>
               </a:rPr>
-              <a:t>The patch redirects recurrent surface cues and records the rejected senses explicitly.</a:t>
+              <a:t>Each row is a corpus example; the local signal selects an output without banning a sense globally.</a:t>
             </a:r>
           </a:p>
         </p:txBody>
@@ -4783,7 +5417,7 @@
       </p:sp>
       <p:graphicFrame>
         <p:nvGraphicFramePr>
-          <p:cNvPr id="9" name=""/>
+          <p:cNvPr id="11" name=""/>
           <p:cNvGraphicFramePr/>
           <p:nvPr/>
         </p:nvGraphicFramePr>
@@ -4816,7 +5450,7 @@
                           <a:ea typeface="Arial"/>
                           <a:cs typeface="Arial"/>
                         </a:rPr>
-                        <a:t>Surface cue</a:t>
+                        <a:t>Corpus text</a:t>
                       </a:r>
                     </a:p>
                   </a:txBody>
@@ -4840,7 +5474,7 @@
                           <a:ea typeface="Arial"/>
                           <a:cs typeface="Arial"/>
                         </a:rPr>
-                        <a:t>Irrelevant raw senses</a:t>
+                        <a:t>Raw collision</a:t>
                       </a:r>
                     </a:p>
                   </a:txBody>
@@ -4864,7 +5498,7 @@
                           <a:ea typeface="Arial"/>
                           <a:cs typeface="Arial"/>
                         </a:rPr>
-                        <a:t>Patched result</a:t>
+                        <a:t>Output</a:t>
                       </a:r>
                     </a:p>
                   </a:txBody>
@@ -4888,7 +5522,7 @@
                           <a:ea typeface="Arial"/>
                           <a:cs typeface="Arial"/>
                         </a:rPr>
-                        <a:t>Explicit suppressions</a:t>
+                        <a:t>Local decision signal</a:t>
                       </a:r>
                     </a:p>
                   </a:txBody>
@@ -4914,7 +5548,7 @@
                           <a:ea typeface="Arial"/>
                           <a:cs typeface="Arial"/>
                         </a:rPr>
-                        <a:t>meet conditions</a:t>
+                        <a:t>“meet entitlement conditions”</a:t>
                       </a:r>
                     </a:p>
                   </a:txBody>
@@ -4986,7 +5620,7 @@
                           <a:ea typeface="Arial"/>
                           <a:cs typeface="Arial"/>
                         </a:rPr>
-                        <a:t>158 + 158</a:t>
+                        <a:t>object = entitlement conditions</a:t>
                       </a:r>
                     </a:p>
                   </a:txBody>
@@ -5012,7 +5646,7 @@
                           <a:ea typeface="Arial"/>
                           <a:cs typeface="Arial"/>
                         </a:rPr>
-                        <a:t>file / submit</a:t>
+                        <a:t>“submit application form”</a:t>
                       </a:r>
                     </a:p>
                   </a:txBody>
@@ -5060,7 +5694,7 @@
                           <a:ea typeface="Arial"/>
                           <a:cs typeface="Arial"/>
                         </a:rPr>
-                        <a:t>Submitting_documents or file reference</a:t>
+                        <a:t>Request + Submitting_documents</a:t>
                       </a:r>
                     </a:p>
                   </a:txBody>
@@ -5084,7 +5718,7 @@
                           <a:ea typeface="Arial"/>
                           <a:cs typeface="Arial"/>
                         </a:rPr>
-                        <a:t>471 + 506</a:t>
+                        <a:t>submit + form / file context</a:t>
                       </a:r>
                     </a:p>
                   </a:txBody>
@@ -5110,7 +5744,7 @@
                           <a:ea typeface="Arial"/>
                           <a:cs typeface="Arial"/>
                         </a:rPr>
-                        <a:t>set value / flag</a:t>
+                        <a:t>“EI premium rates”</a:t>
                       </a:r>
                     </a:p>
                   </a:txBody>
@@ -5134,7 +5768,7 @@
                           <a:ea typeface="Arial"/>
                           <a:cs typeface="Arial"/>
                         </a:rPr>
-                        <a:t>Consistency-change pair</a:t>
+                        <a:t>Rate_quantification; Unemployment_rate</a:t>
                       </a:r>
                     </a:p>
                   </a:txBody>
@@ -5158,7 +5792,7 @@
                           <a:ea typeface="Arial"/>
                           <a:cs typeface="Arial"/>
                         </a:rPr>
-                        <a:t>Structured administrative setting</a:t>
+                        <a:t>structured rate_or_ratio</a:t>
                       </a:r>
                     </a:p>
                   </a:txBody>
@@ -5182,7 +5816,7 @@
                           <a:ea typeface="Arial"/>
                           <a:cs typeface="Arial"/>
                         </a:rPr>
-                        <a:t>10 + 11</a:t>
+                        <a:t>rate phrase; quantity, not event</a:t>
                       </a:r>
                     </a:p>
                   </a:txBody>
@@ -5208,7 +5842,7 @@
                           <a:ea typeface="Arial"/>
                           <a:cs typeface="Arial"/>
                         </a:rPr>
-                        <a:t>rate / ratio</a:t>
+                        <a:t>“proof of death received”</a:t>
                       </a:r>
                     </a:p>
                   </a:txBody>
@@ -5232,7 +5866,7 @@
                           <a:ea typeface="Arial"/>
                           <a:cs typeface="Arial"/>
                         </a:rPr>
-                        <a:t>Rate_quantification; Relational_quantity; Unemployment_rate</a:t>
+                        <a:t>Control; Contingency; Deciding</a:t>
                       </a:r>
                     </a:p>
                   </a:txBody>
@@ -5256,7 +5890,7 @@
                           <a:ea typeface="Arial"/>
                           <a:cs typeface="Arial"/>
                         </a:rPr>
-                        <a:t>Structured rate_or_ratio</a:t>
+                        <a:t>Coming_to_believe + Evidence</a:t>
                       </a:r>
                     </a:p>
                   </a:txBody>
@@ -5280,7 +5914,7 @@
                           <a:ea typeface="Arial"/>
                           <a:cs typeface="Arial"/>
                         </a:rPr>
-                        <a:t>104 + 104 + 198</a:t>
+                        <a:t>proof / received evidence basis</a:t>
                       </a:r>
                     </a:p>
                   </a:txBody>
@@ -5306,7 +5940,7 @@
                           <a:ea typeface="Arial"/>
                           <a:cs typeface="Arial"/>
                         </a:rPr>
-                        <a:t>determine</a:t>
+                        <a:t>“Employment Insurance title”</a:t>
                       </a:r>
                     </a:p>
                   </a:txBody>
@@ -5330,7 +5964,7 @@
                           <a:ea typeface="Arial"/>
                           <a:cs typeface="Arial"/>
                         </a:rPr>
-                        <a:t>Control; Contingency</a:t>
+                        <a:t>Being_employed; Resolve_problem</a:t>
                       </a:r>
                     </a:p>
                   </a:txBody>
@@ -5354,7 +5988,7 @@
                           <a:ea typeface="Arial"/>
                           <a:cs typeface="Arial"/>
                         </a:rPr>
-                        <a:t>Deciding, Assessing or Coming_to_believe</a:t>
+                        <a:t>needs_review</a:t>
                       </a:r>
                     </a:p>
                   </a:txBody>
@@ -5378,7 +6012,7 @@
                           <a:ea typeface="Arial"/>
                           <a:cs typeface="Arial"/>
                         </a:rPr>
-                        <a:t>3,335 + 3,335</a:t>
+                        <a:t>program title, not job status</a:t>
                       </a:r>
                     </a:p>
                   </a:txBody>
@@ -5450,7 +6084,7 @@
                 <a:ea typeface="Arial"/>
                 <a:cs typeface="Arial"/>
               </a:rPr>
-              <a:t>Counts are corpus occurrences in the explicit-suppression audit. The rejected senses are absent from canonical output.</a:t>
+              <a:t>Frame selection only—not FE-role validation. Suppression is contextual; legitimate senses remain available elsewhere.</a:t>
             </a:r>
           </a:p>
         </p:txBody>
@@ -5541,7 +6175,7 @@
                 <a:ea typeface="Arial"/>
                 <a:cs typeface="Arial"/>
               </a:rPr>
-              <a:t>Proceed with the candidate-narrowing layer</a:t>
+              <a:t>Proceed to validation—not production</a:t>
             </a:r>
           </a:p>
         </p:txBody>
@@ -5603,7 +6237,7 @@
                 <a:ea typeface="Arial"/>
                 <a:cs typeface="Arial"/>
               </a:rPr>
-              <a:t>The direction is right if the review queue and structured non-frame path remain first-class outputs.</a:t>
+              <a:t>The patch is suitable as a candidate-narrowing layer; release depends on measured accuracy and an accepted review workflow.</a:t>
             </a:r>
           </a:p>
         </p:txBody>
@@ -5793,7 +6427,7 @@
                 <a:ea typeface="Arial"/>
                 <a:cs typeface="Arial"/>
               </a:rPr>
-              <a:t>Adopt now</a:t>
+              <a:t>Gold-set design</a:t>
             </a:r>
           </a:p>
         </p:txBody>
@@ -5855,7 +6489,7 @@
                 <a:ea typeface="Arial"/>
                 <a:cs typeface="Arial"/>
               </a:rPr>
-              <a:t>Use the 26-frame domain cap and the 11,434 high-confidence canonical sentences downstream.</a:t>
+              <a:t>300 sentences across top frames, collision rules, review and no-domain. Dual annotation + adjudication; assess FEs separately.</a:t>
             </a:r>
           </a:p>
         </p:txBody>
@@ -5983,7 +6617,7 @@
                 <a:ea typeface="Arial"/>
                 <a:cs typeface="Arial"/>
               </a:rPr>
-              <a:t>Keep the guardrail</a:t>
+              <a:t>Proposed release gate</a:t>
             </a:r>
           </a:p>
         </p:txBody>
@@ -6045,7 +6679,7 @@
                 <a:ea typeface="Arial"/>
                 <a:cs typeface="Arial"/>
               </a:rPr>
-              <a:t>Never auto-promote the 4,075 review cases; retain quantities and record labels outside the frame inventory.</a:t>
+              <a:t>≥90% canonical precision overall; publish per-frame precision / recall; require a client-approved floor for high-volume rules.</a:t>
             </a:r>
           </a:p>
         </p:txBody>
@@ -6173,7 +6807,7 @@
                 <a:ea typeface="Arial"/>
                 <a:cs typeface="Arial"/>
               </a:rPr>
-              <a:t>Validate frame elements</a:t>
+              <a:t>Human review plan</a:t>
             </a:r>
           </a:p>
         </p:txBody>
@@ -6235,7 +6869,7 @@
                 <a:ea typeface="Arial"/>
                 <a:cs typeface="Arial"/>
               </a:rPr>
-              <a:t>Build a 300-sentence stratified gold set and check roles for the top frames plus collision-heavy review cases.</a:t>
+              <a:t>Queue = 4,075 review + 1,625 no-domain. Time 100 pilot items; staffing = queue × median minutes per item.</a:t>
             </a:r>
           </a:p>
         </p:txBody>
@@ -6363,7 +6997,7 @@
                 <a:ea typeface="Arial"/>
                 <a:cs typeface="Arial"/>
               </a:rPr>
-              <a:t>Next patch target</a:t>
+              <a:t>Version and rollback</a:t>
             </a:r>
           </a:p>
         </p:txBody>
@@ -6425,7 +7059,7 @@
                 <a:ea typeface="Arial"/>
                 <a:cs typeface="Arial"/>
               </a:rPr>
-              <a:t>Prioritize the 1,625 no-domain sentences and recurrent review clusters; add rules only with measured precision.</a:t>
+              <a:t>procedure-domain-v1 retains raw candidates, rules, suppressions and review candidates. Compare before promotion; rollback by rerun.</a:t>
             </a:r>
           </a:p>
         </p:txBody>
@@ -6487,7 +7121,7 @@
                 <a:ea typeface="Arial"/>
                 <a:cs typeface="Arial"/>
               </a:rPr>
-              <a:t>Observed on 17,244 sentences • 19 focused unit tests passed • median canonical count = 1</a:t>
+              <a:t>Decision today: validation only • 17,244 sentences rerun • 37 tests passed • no gold-set accuracy yet</a:t>
             </a:r>
           </a:p>
         </p:txBody>

</xml_diff>